<commit_message>
align PowerPoint figure slides with PDF layout
</commit_message>
<xml_diff>
--- a/results/fresh/presentation/Wildboar_Consulting_Presentation.pptx
+++ b/results/fresh/presentation/Wildboar_Consulting_Presentation.pptx
@@ -5110,9 +5110,107 @@
           </a:p>
         </p:txBody>
       </p:sp>
+      <p:sp>
+        <p:nvSpPr>
+          <p:cNvPr id="3" name=""/>
+          <p:cNvSpPr>
+            <a:spLocks noGrp="1"/>
+          </p:cNvSpPr>
+          <p:nvPr>
+            <p:ph/>
+          </p:nvPr>
+        </p:nvSpPr>
+        <p:spPr>
+          <a:xfrm>
+            <a:off x="594360" y="1024128"/>
+            <a:ext cx="7955280" cy="347472"/>
+          </a:xfrm>
+        </p:spPr>
+        <p:txBody>
+          <a:bodyPr/>
+          <a:lstStyle/>
+          <a:p>
+            <a:pPr algn="l" marL="0" marR="0">
+              <a:lnSpc>
+                <a:spcPct val="100000"/>
+              </a:lnSpc>
+              <a:spcBef>
+                <a:spcPts val="0"/>
+              </a:spcBef>
+              <a:spcAft>
+                <a:spcPts val="0"/>
+              </a:spcAft>
+              <a:buNone/>
+            </a:pPr>
+            <a:r>
+              <a:rPr cap="none" sz="1700" i="0" b="0" u="none" strike="noStrike">
+                <a:solidFill>
+                  <a:srgbClr val="16324F">
+                    <a:alpha val="100000"/>
+                  </a:srgbClr>
+                </a:solidFill>
+                <a:latin typeface="Arial"/>
+                <a:cs typeface="Arial"/>
+                <a:ea typeface="Arial"/>
+                <a:sym typeface="Arial"/>
+              </a:rPr>
+              <a:t>• Ordinal polychorics, minres extraction, oblimin rotation</a:t>
+            </a:r>
+          </a:p>
+        </p:txBody>
+      </p:sp>
+      <p:sp>
+        <p:nvSpPr>
+          <p:cNvPr id="4" name=""/>
+          <p:cNvSpPr>
+            <a:spLocks noGrp="1"/>
+          </p:cNvSpPr>
+          <p:nvPr>
+            <p:ph/>
+          </p:nvPr>
+        </p:nvSpPr>
+        <p:spPr>
+          <a:xfrm>
+            <a:off x="594360" y="1408176"/>
+            <a:ext cx="7955280" cy="347472"/>
+          </a:xfrm>
+        </p:spPr>
+        <p:txBody>
+          <a:bodyPr/>
+          <a:lstStyle/>
+          <a:p>
+            <a:pPr algn="l" marL="0" marR="0">
+              <a:lnSpc>
+                <a:spcPct val="100000"/>
+              </a:lnSpc>
+              <a:spcBef>
+                <a:spcPts val="0"/>
+              </a:spcBef>
+              <a:spcAft>
+                <a:spcPts val="0"/>
+              </a:spcAft>
+              <a:buNone/>
+            </a:pPr>
+            <a:r>
+              <a:rPr cap="none" sz="1700" i="0" b="0" u="none" strike="noStrike">
+                <a:solidFill>
+                  <a:srgbClr val="16324F">
+                    <a:alpha val="100000"/>
+                  </a:srgbClr>
+                </a:solidFill>
+                <a:latin typeface="Arial"/>
+                <a:cs typeface="Arial"/>
+                <a:ea typeface="Arial"/>
+                <a:sym typeface="Arial"/>
+              </a:rPr>
+              <a:t>• Parallel analysis and identification must be read together</a:t>
+            </a:r>
+          </a:p>
+        </p:txBody>
+      </p:sp>
       <p:pic>
         <p:nvPicPr>
-          <p:cNvPr id="3" name="" descr=""/>
+          <p:cNvPr id="5" name="" descr=""/>
           <p:cNvPicPr>
             <a:picLocks noGrp="1"/>
           </p:cNvPicPr>
@@ -5128,8 +5226,8 @@
         </p:blipFill>
         <p:spPr>
           <a:xfrm>
-            <a:off x="502920" y="1188720"/>
-            <a:ext cx="8138160" cy="4480560"/>
+            <a:off x="502920" y="1847088"/>
+            <a:ext cx="8138160" cy="4160520"/>
           </a:xfrm>
           <a:prstGeom prst="rect">
             <a:avLst/>
@@ -5138,57 +5236,7 @@
       </p:pic>
       <p:sp>
         <p:nvSpPr>
-          <p:cNvPr id="4" name=""/>
-          <p:cNvSpPr>
-            <a:spLocks noGrp="1"/>
-          </p:cNvSpPr>
-          <p:nvPr>
-            <p:ph/>
-          </p:nvPr>
-        </p:nvSpPr>
-        <p:spPr>
-          <a:xfrm>
-            <a:off x="502920" y="5669280"/>
-            <a:ext cx="8138160" cy="640080"/>
-          </a:xfrm>
-        </p:spPr>
-        <p:txBody>
-          <a:bodyPr/>
-          <a:lstStyle/>
-          <a:p>
-            <a:pPr algn="l" marL="0" marR="0">
-              <a:lnSpc>
-                <a:spcPct val="100000"/>
-              </a:lnSpc>
-              <a:spcBef>
-                <a:spcPts val="0"/>
-              </a:spcBef>
-              <a:spcAft>
-                <a:spcPts val="0"/>
-              </a:spcAft>
-              <a:buNone/>
-            </a:pPr>
-            <a:r>
-              <a:rPr cap="none" sz="1500" i="0" b="0" u="none" strike="noStrike">
-                <a:solidFill>
-                  <a:srgbClr val="16324F">
-                    <a:alpha val="100000"/>
-                  </a:srgbClr>
-                </a:solidFill>
-                <a:latin typeface="Arial"/>
-                <a:cs typeface="Arial"/>
-                <a:ea typeface="Arial"/>
-                <a:sym typeface="Arial"/>
-              </a:rPr>
-              <a:t>Ordinal polychorics, minres extraction, oblimin rotation
-Parallel analysis and identification must be read together</a:t>
-            </a:r>
-          </a:p>
-        </p:txBody>
-      </p:sp>
-      <p:sp>
-        <p:nvSpPr>
-          <p:cNvPr id="5" name=""/>
+          <p:cNvPr id="6" name=""/>
           <p:cNvSpPr>
             <a:spLocks noGrp="1"/>
           </p:cNvSpPr>
@@ -5579,9 +5627,156 @@
           </a:p>
         </p:txBody>
       </p:sp>
+      <p:sp>
+        <p:nvSpPr>
+          <p:cNvPr id="3" name=""/>
+          <p:cNvSpPr>
+            <a:spLocks noGrp="1"/>
+          </p:cNvSpPr>
+          <p:nvPr>
+            <p:ph/>
+          </p:nvPr>
+        </p:nvSpPr>
+        <p:spPr>
+          <a:xfrm>
+            <a:off x="594360" y="1024128"/>
+            <a:ext cx="7955280" cy="347472"/>
+          </a:xfrm>
+        </p:spPr>
+        <p:txBody>
+          <a:bodyPr/>
+          <a:lstStyle/>
+          <a:p>
+            <a:pPr algn="l" marL="0" marR="0">
+              <a:lnSpc>
+                <a:spcPct val="100000"/>
+              </a:lnSpc>
+              <a:spcBef>
+                <a:spcPts val="0"/>
+              </a:spcBef>
+              <a:spcAft>
+                <a:spcPts val="0"/>
+              </a:spcAft>
+              <a:buNone/>
+            </a:pPr>
+            <a:r>
+              <a:rPr cap="none" sz="1700" i="0" b="0" u="none" strike="noStrike">
+                <a:solidFill>
+                  <a:srgbClr val="16324F">
+                    <a:alpha val="100000"/>
+                  </a:srgbClr>
+                </a:solidFill>
+                <a:latin typeface="Arial"/>
+                <a:cs typeface="Arial"/>
+                <a:ea typeface="Arial"/>
+                <a:sym typeface="Arial"/>
+              </a:rPr>
+              <a:t>• Standardized complete-case item PCA</a:t>
+            </a:r>
+          </a:p>
+        </p:txBody>
+      </p:sp>
+      <p:sp>
+        <p:nvSpPr>
+          <p:cNvPr id="4" name=""/>
+          <p:cNvSpPr>
+            <a:spLocks noGrp="1"/>
+          </p:cNvSpPr>
+          <p:nvPr>
+            <p:ph/>
+          </p:nvPr>
+        </p:nvSpPr>
+        <p:spPr>
+          <a:xfrm>
+            <a:off x="594360" y="1408176"/>
+            <a:ext cx="7955280" cy="347472"/>
+          </a:xfrm>
+        </p:spPr>
+        <p:txBody>
+          <a:bodyPr/>
+          <a:lstStyle/>
+          <a:p>
+            <a:pPr algn="l" marL="0" marR="0">
+              <a:lnSpc>
+                <a:spcPct val="100000"/>
+              </a:lnSpc>
+              <a:spcBef>
+                <a:spcPts val="0"/>
+              </a:spcBef>
+              <a:spcAft>
+                <a:spcPts val="0"/>
+              </a:spcAft>
+              <a:buNone/>
+            </a:pPr>
+            <a:r>
+              <a:rPr cap="none" sz="1700" i="0" b="0" u="none" strike="noStrike">
+                <a:solidFill>
+                  <a:srgbClr val="16324F">
+                    <a:alpha val="100000"/>
+                  </a:srgbClr>
+                </a:solidFill>
+                <a:latin typeface="Arial"/>
+                <a:cs typeface="Arial"/>
+                <a:ea typeface="Arial"/>
+                <a:sym typeface="Arial"/>
+              </a:rPr>
+              <a:t>• Loadings and explained variance supplied</a:t>
+            </a:r>
+          </a:p>
+        </p:txBody>
+      </p:sp>
+      <p:sp>
+        <p:nvSpPr>
+          <p:cNvPr id="5" name=""/>
+          <p:cNvSpPr>
+            <a:spLocks noGrp="1"/>
+          </p:cNvSpPr>
+          <p:nvPr>
+            <p:ph/>
+          </p:nvPr>
+        </p:nvSpPr>
+        <p:spPr>
+          <a:xfrm>
+            <a:off x="594360" y="1792224"/>
+            <a:ext cx="7955280" cy="347472"/>
+          </a:xfrm>
+        </p:spPr>
+        <p:txBody>
+          <a:bodyPr/>
+          <a:lstStyle/>
+          <a:p>
+            <a:pPr algn="l" marL="0" marR="0">
+              <a:lnSpc>
+                <a:spcPct val="100000"/>
+              </a:lnSpc>
+              <a:spcBef>
+                <a:spcPts val="0"/>
+              </a:spcBef>
+              <a:spcAft>
+                <a:spcPts val="0"/>
+              </a:spcAft>
+              <a:buNone/>
+            </a:pPr>
+            <a:r>
+              <a:rPr cap="none" sz="1700" i="0" b="0" u="none" strike="noStrike">
+                <a:solidFill>
+                  <a:srgbClr val="16324F">
+                    <a:alpha val="100000"/>
+                  </a:srgbClr>
+                </a:solidFill>
+                <a:latin typeface="Arial"/>
+                <a:cs typeface="Arial"/>
+                <a:ea typeface="Arial"/>
+                <a:sym typeface="Arial"/>
+              </a:rPr>
+              <a:t>• PCA components are not latent causes, IRT, or PLS-SEM</a:t>
+            </a:r>
+          </a:p>
+        </p:txBody>
+      </p:sp>
       <p:pic>
         <p:nvPicPr>
-          <p:cNvPr id="3" name="" descr=""/>
+          <p:cNvPr id="6" name="" descr=""/>
           <p:cNvPicPr>
             <a:picLocks noGrp="1"/>
           </p:cNvPicPr>
@@ -5597,8 +5792,8 @@
         </p:blipFill>
         <p:spPr>
           <a:xfrm>
-            <a:off x="502920" y="1188720"/>
-            <a:ext cx="8138160" cy="4480560"/>
+            <a:off x="502920" y="1847088"/>
+            <a:ext cx="8138160" cy="4160520"/>
           </a:xfrm>
           <a:prstGeom prst="rect">
             <a:avLst/>
@@ -5607,58 +5802,7 @@
       </p:pic>
       <p:sp>
         <p:nvSpPr>
-          <p:cNvPr id="4" name=""/>
-          <p:cNvSpPr>
-            <a:spLocks noGrp="1"/>
-          </p:cNvSpPr>
-          <p:nvPr>
-            <p:ph/>
-          </p:nvPr>
-        </p:nvSpPr>
-        <p:spPr>
-          <a:xfrm>
-            <a:off x="502920" y="5669280"/>
-            <a:ext cx="8138160" cy="640080"/>
-          </a:xfrm>
-        </p:spPr>
-        <p:txBody>
-          <a:bodyPr/>
-          <a:lstStyle/>
-          <a:p>
-            <a:pPr algn="l" marL="0" marR="0">
-              <a:lnSpc>
-                <a:spcPct val="100000"/>
-              </a:lnSpc>
-              <a:spcBef>
-                <a:spcPts val="0"/>
-              </a:spcBef>
-              <a:spcAft>
-                <a:spcPts val="0"/>
-              </a:spcAft>
-              <a:buNone/>
-            </a:pPr>
-            <a:r>
-              <a:rPr cap="none" sz="1500" i="0" b="0" u="none" strike="noStrike">
-                <a:solidFill>
-                  <a:srgbClr val="16324F">
-                    <a:alpha val="100000"/>
-                  </a:srgbClr>
-                </a:solidFill>
-                <a:latin typeface="Arial"/>
-                <a:cs typeface="Arial"/>
-                <a:ea typeface="Arial"/>
-                <a:sym typeface="Arial"/>
-              </a:rPr>
-              <a:t>Standardized complete-case item PCA
-Loadings and explained variance supplied
-PCA components are not latent causes, IRT, or PLS-SEM</a:t>
-            </a:r>
-          </a:p>
-        </p:txBody>
-      </p:sp>
-      <p:sp>
-        <p:nvSpPr>
-          <p:cNvPr id="5" name=""/>
+          <p:cNvPr id="7" name=""/>
           <p:cNvSpPr>
             <a:spLocks noGrp="1"/>
           </p:cNvSpPr>
@@ -6368,9 +6512,58 @@
           </a:p>
         </p:txBody>
       </p:sp>
+      <p:sp>
+        <p:nvSpPr>
+          <p:cNvPr id="3" name=""/>
+          <p:cNvSpPr>
+            <a:spLocks noGrp="1"/>
+          </p:cNvSpPr>
+          <p:nvPr>
+            <p:ph/>
+          </p:nvPr>
+        </p:nvSpPr>
+        <p:spPr>
+          <a:xfrm>
+            <a:off x="594360" y="1024128"/>
+            <a:ext cx="7955280" cy="347472"/>
+          </a:xfrm>
+        </p:spPr>
+        <p:txBody>
+          <a:bodyPr/>
+          <a:lstStyle/>
+          <a:p>
+            <a:pPr algn="l" marL="0" marR="0">
+              <a:lnSpc>
+                <a:spcPct val="100000"/>
+              </a:lnSpc>
+              <a:spcBef>
+                <a:spcPts val="0"/>
+              </a:spcBef>
+              <a:spcAft>
+                <a:spcPts val="0"/>
+              </a:spcAft>
+              <a:buNone/>
+            </a:pPr>
+            <a:r>
+              <a:rPr cap="none" sz="1700" i="0" b="0" u="none" strike="noStrike">
+                <a:solidFill>
+                  <a:srgbClr val="16324F">
+                    <a:alpha val="100000"/>
+                  </a:srgbClr>
+                </a:solidFill>
+                <a:latin typeface="Arial"/>
+                <a:cs typeface="Arial"/>
+                <a:ea typeface="Arial"/>
+                <a:sym typeface="Arial"/>
+              </a:rPr>
+              <a:t>• The strongest background-adjusted signal concerns non-lethal management.</a:t>
+            </a:r>
+          </a:p>
+        </p:txBody>
+      </p:sp>
       <p:pic>
         <p:nvPicPr>
-          <p:cNvPr id="3" name="" descr=""/>
+          <p:cNvPr id="4" name="" descr=""/>
           <p:cNvPicPr>
             <a:picLocks noGrp="1"/>
           </p:cNvPicPr>
@@ -6386,63 +6579,14 @@
         </p:blipFill>
         <p:spPr>
           <a:xfrm>
-            <a:off x="502920" y="1188720"/>
-            <a:ext cx="8138160" cy="4480560"/>
+            <a:off x="502920" y="1847088"/>
+            <a:ext cx="8138160" cy="4160520"/>
           </a:xfrm>
           <a:prstGeom prst="rect">
             <a:avLst/>
           </a:prstGeom>
         </p:spPr>
       </p:pic>
-      <p:sp>
-        <p:nvSpPr>
-          <p:cNvPr id="4" name=""/>
-          <p:cNvSpPr>
-            <a:spLocks noGrp="1"/>
-          </p:cNvSpPr>
-          <p:nvPr>
-            <p:ph/>
-          </p:nvPr>
-        </p:nvSpPr>
-        <p:spPr>
-          <a:xfrm>
-            <a:off x="502920" y="5669280"/>
-            <a:ext cx="8138160" cy="640080"/>
-          </a:xfrm>
-        </p:spPr>
-        <p:txBody>
-          <a:bodyPr/>
-          <a:lstStyle/>
-          <a:p>
-            <a:pPr algn="l" marL="0" marR="0">
-              <a:lnSpc>
-                <a:spcPct val="100000"/>
-              </a:lnSpc>
-              <a:spcBef>
-                <a:spcPts val="0"/>
-              </a:spcBef>
-              <a:spcAft>
-                <a:spcPts val="0"/>
-              </a:spcAft>
-              <a:buNone/>
-            </a:pPr>
-            <a:r>
-              <a:rPr cap="none" sz="1500" i="0" b="0" u="none" strike="noStrike">
-                <a:solidFill>
-                  <a:srgbClr val="16324F">
-                    <a:alpha val="100000"/>
-                  </a:srgbClr>
-                </a:solidFill>
-                <a:latin typeface="Arial"/>
-                <a:cs typeface="Arial"/>
-                <a:ea typeface="Arial"/>
-                <a:sym typeface="Arial"/>
-              </a:rPr>
-              <a:t>The strongest background-adjusted signal concerns non-lethal management.</a:t>
-            </a:r>
-          </a:p>
-        </p:txBody>
-      </p:sp>
       <p:sp>
         <p:nvSpPr>
           <p:cNvPr id="5" name=""/>
@@ -6566,9 +6710,58 @@
           </a:p>
         </p:txBody>
       </p:sp>
+      <p:sp>
+        <p:nvSpPr>
+          <p:cNvPr id="3" name=""/>
+          <p:cNvSpPr>
+            <a:spLocks noGrp="1"/>
+          </p:cNvSpPr>
+          <p:nvPr>
+            <p:ph/>
+          </p:nvPr>
+        </p:nvSpPr>
+        <p:spPr>
+          <a:xfrm>
+            <a:off x="594360" y="1024128"/>
+            <a:ext cx="7955280" cy="347472"/>
+          </a:xfrm>
+        </p:spPr>
+        <p:txBody>
+          <a:bodyPr/>
+          <a:lstStyle/>
+          <a:p>
+            <a:pPr algn="l" marL="0" marR="0">
+              <a:lnSpc>
+                <a:spcPct val="100000"/>
+              </a:lnSpc>
+              <a:spcBef>
+                <a:spcPts val="0"/>
+              </a:spcBef>
+              <a:spcAft>
+                <a:spcPts val="0"/>
+              </a:spcAft>
+              <a:buNone/>
+            </a:pPr>
+            <a:r>
+              <a:rPr cap="none" sz="1700" i="0" b="0" u="none" strike="noStrike">
+                <a:solidFill>
+                  <a:srgbClr val="16324F">
+                    <a:alpha val="100000"/>
+                  </a:srgbClr>
+                </a:solidFill>
+                <a:latin typeface="Arial"/>
+                <a:cs typeface="Arial"/>
+                <a:ea typeface="Arial"/>
+                <a:sym typeface="Arial"/>
+              </a:rPr>
+              <a:t>• Three- and four-item scores are secondary summaries.</a:t>
+            </a:r>
+          </a:p>
+        </p:txBody>
+      </p:sp>
       <p:pic>
         <p:nvPicPr>
-          <p:cNvPr id="3" name="" descr=""/>
+          <p:cNvPr id="4" name="" descr=""/>
           <p:cNvPicPr>
             <a:picLocks noGrp="1"/>
           </p:cNvPicPr>
@@ -6584,63 +6777,14 @@
         </p:blipFill>
         <p:spPr>
           <a:xfrm>
-            <a:off x="502920" y="1188720"/>
-            <a:ext cx="8138160" cy="4480560"/>
+            <a:off x="502920" y="1847088"/>
+            <a:ext cx="8138160" cy="4160520"/>
           </a:xfrm>
           <a:prstGeom prst="rect">
             <a:avLst/>
           </a:prstGeom>
         </p:spPr>
       </p:pic>
-      <p:sp>
-        <p:nvSpPr>
-          <p:cNvPr id="4" name=""/>
-          <p:cNvSpPr>
-            <a:spLocks noGrp="1"/>
-          </p:cNvSpPr>
-          <p:nvPr>
-            <p:ph/>
-          </p:nvPr>
-        </p:nvSpPr>
-        <p:spPr>
-          <a:xfrm>
-            <a:off x="502920" y="5669280"/>
-            <a:ext cx="8138160" cy="640080"/>
-          </a:xfrm>
-        </p:spPr>
-        <p:txBody>
-          <a:bodyPr/>
-          <a:lstStyle/>
-          <a:p>
-            <a:pPr algn="l" marL="0" marR="0">
-              <a:lnSpc>
-                <a:spcPct val="100000"/>
-              </a:lnSpc>
-              <a:spcBef>
-                <a:spcPts val="0"/>
-              </a:spcBef>
-              <a:spcAft>
-                <a:spcPts val="0"/>
-              </a:spcAft>
-              <a:buNone/>
-            </a:pPr>
-            <a:r>
-              <a:rPr cap="none" sz="1500" i="0" b="0" u="none" strike="noStrike">
-                <a:solidFill>
-                  <a:srgbClr val="16324F">
-                    <a:alpha val="100000"/>
-                  </a:srgbClr>
-                </a:solidFill>
-                <a:latin typeface="Arial"/>
-                <a:cs typeface="Arial"/>
-                <a:ea typeface="Arial"/>
-                <a:sym typeface="Arial"/>
-              </a:rPr>
-              <a:t>Three- and four-item scores are secondary summaries.</a:t>
-            </a:r>
-          </a:p>
-        </p:txBody>
-      </p:sp>
       <p:sp>
         <p:nvSpPr>
           <p:cNvPr id="5" name=""/>
@@ -7574,9 +7718,58 @@
           </a:p>
         </p:txBody>
       </p:sp>
+      <p:sp>
+        <p:nvSpPr>
+          <p:cNvPr id="3" name=""/>
+          <p:cNvSpPr>
+            <a:spLocks noGrp="1"/>
+          </p:cNvSpPr>
+          <p:nvPr>
+            <p:ph/>
+          </p:nvPr>
+        </p:nvSpPr>
+        <p:spPr>
+          <a:xfrm>
+            <a:off x="594360" y="1024128"/>
+            <a:ext cx="7955280" cy="347472"/>
+          </a:xfrm>
+        </p:spPr>
+        <p:txBody>
+          <a:bodyPr/>
+          <a:lstStyle/>
+          <a:p>
+            <a:pPr algn="l" marL="0" marR="0">
+              <a:lnSpc>
+                <a:spcPct val="100000"/>
+              </a:lnSpc>
+              <a:spcBef>
+                <a:spcPts val="0"/>
+              </a:spcBef>
+              <a:spcAft>
+                <a:spcPts val="0"/>
+              </a:spcAft>
+              <a:buNone/>
+            </a:pPr>
+            <a:r>
+              <a:rPr cap="none" sz="1700" i="0" b="0" u="none" strike="noStrike">
+                <a:solidFill>
+                  <a:srgbClr val="16324F">
+                    <a:alpha val="100000"/>
+                  </a:srgbClr>
+                </a:solidFill>
+                <a:latin typeface="Arial"/>
+                <a:cs typeface="Arial"/>
+                <a:ea typeface="Arial"/>
+                <a:sym typeface="Arial"/>
+              </a:rPr>
+              <a:t>• Intervals come from 5,000 county-stratified township resamples.</a:t>
+            </a:r>
+          </a:p>
+        </p:txBody>
+      </p:sp>
       <p:pic>
         <p:nvPicPr>
-          <p:cNvPr id="3" name="" descr=""/>
+          <p:cNvPr id="4" name="" descr=""/>
           <p:cNvPicPr>
             <a:picLocks noGrp="1"/>
           </p:cNvPicPr>
@@ -7592,63 +7785,14 @@
         </p:blipFill>
         <p:spPr>
           <a:xfrm>
-            <a:off x="502920" y="1188720"/>
-            <a:ext cx="8138160" cy="4480560"/>
+            <a:off x="502920" y="1847088"/>
+            <a:ext cx="8138160" cy="4160520"/>
           </a:xfrm>
           <a:prstGeom prst="rect">
             <a:avLst/>
           </a:prstGeom>
         </p:spPr>
       </p:pic>
-      <p:sp>
-        <p:nvSpPr>
-          <p:cNvPr id="4" name=""/>
-          <p:cNvSpPr>
-            <a:spLocks noGrp="1"/>
-          </p:cNvSpPr>
-          <p:nvPr>
-            <p:ph/>
-          </p:nvPr>
-        </p:nvSpPr>
-        <p:spPr>
-          <a:xfrm>
-            <a:off x="502920" y="5669280"/>
-            <a:ext cx="8138160" cy="640080"/>
-          </a:xfrm>
-        </p:spPr>
-        <p:txBody>
-          <a:bodyPr/>
-          <a:lstStyle/>
-          <a:p>
-            <a:pPr algn="l" marL="0" marR="0">
-              <a:lnSpc>
-                <a:spcPct val="100000"/>
-              </a:lnSpc>
-              <a:spcBef>
-                <a:spcPts val="0"/>
-              </a:spcBef>
-              <a:spcAft>
-                <a:spcPts val="0"/>
-              </a:spcAft>
-              <a:buNone/>
-            </a:pPr>
-            <a:r>
-              <a:rPr cap="none" sz="1500" i="0" b="0" u="none" strike="noStrike">
-                <a:solidFill>
-                  <a:srgbClr val="16324F">
-                    <a:alpha val="100000"/>
-                  </a:srgbClr>
-                </a:solidFill>
-                <a:latin typeface="Arial"/>
-                <a:cs typeface="Arial"/>
-                <a:ea typeface="Arial"/>
-                <a:sym typeface="Arial"/>
-              </a:rPr>
-              <a:t>Intervals come from 5,000 county-stratified township resamples.</a:t>
-            </a:r>
-          </a:p>
-        </p:txBody>
-      </p:sp>
       <p:sp>
         <p:nvSpPr>
           <p:cNvPr id="5" name=""/>
@@ -8729,9 +8873,58 @@
           </a:p>
         </p:txBody>
       </p:sp>
+      <p:sp>
+        <p:nvSpPr>
+          <p:cNvPr id="3" name=""/>
+          <p:cNvSpPr>
+            <a:spLocks noGrp="1"/>
+          </p:cNvSpPr>
+          <p:nvPr>
+            <p:ph/>
+          </p:nvPr>
+        </p:nvSpPr>
+        <p:spPr>
+          <a:xfrm>
+            <a:off x="594360" y="1024128"/>
+            <a:ext cx="7955280" cy="347472"/>
+          </a:xfrm>
+        </p:spPr>
+        <p:txBody>
+          <a:bodyPr/>
+          <a:lstStyle/>
+          <a:p>
+            <a:pPr algn="l" marL="0" marR="0">
+              <a:lnSpc>
+                <a:spcPct val="100000"/>
+              </a:lnSpc>
+              <a:spcBef>
+                <a:spcPts val="0"/>
+              </a:spcBef>
+              <a:spcAft>
+                <a:spcPts val="0"/>
+              </a:spcAft>
+              <a:buNone/>
+            </a:pPr>
+            <a:r>
+              <a:rPr cap="none" sz="1700" i="0" b="0" u="none" strike="noStrike">
+                <a:solidFill>
+                  <a:srgbClr val="16324F">
+                    <a:alpha val="100000"/>
+                  </a:srgbClr>
+                </a:solidFill>
+                <a:latin typeface="Arial"/>
+                <a:cs typeface="Arial"/>
+                <a:ea typeface="Arial"/>
+                <a:sym typeface="Arial"/>
+              </a:rPr>
+              <a:t>• Best observed grouped-CV RMSE: 0.537 (elastic_net)</a:t>
+            </a:r>
+          </a:p>
+        </p:txBody>
+      </p:sp>
       <p:pic>
         <p:nvPicPr>
-          <p:cNvPr id="3" name="" descr=""/>
+          <p:cNvPr id="4" name="" descr=""/>
           <p:cNvPicPr>
             <a:picLocks noGrp="1"/>
           </p:cNvPicPr>
@@ -8747,63 +8940,14 @@
         </p:blipFill>
         <p:spPr>
           <a:xfrm>
-            <a:off x="502920" y="1188720"/>
-            <a:ext cx="8138160" cy="4480560"/>
+            <a:off x="502920" y="1847088"/>
+            <a:ext cx="8138160" cy="4160520"/>
           </a:xfrm>
           <a:prstGeom prst="rect">
             <a:avLst/>
           </a:prstGeom>
         </p:spPr>
       </p:pic>
-      <p:sp>
-        <p:nvSpPr>
-          <p:cNvPr id="4" name=""/>
-          <p:cNvSpPr>
-            <a:spLocks noGrp="1"/>
-          </p:cNvSpPr>
-          <p:nvPr>
-            <p:ph/>
-          </p:nvPr>
-        </p:nvSpPr>
-        <p:spPr>
-          <a:xfrm>
-            <a:off x="502920" y="5669280"/>
-            <a:ext cx="8138160" cy="640080"/>
-          </a:xfrm>
-        </p:spPr>
-        <p:txBody>
-          <a:bodyPr/>
-          <a:lstStyle/>
-          <a:p>
-            <a:pPr algn="l" marL="0" marR="0">
-              <a:lnSpc>
-                <a:spcPct val="100000"/>
-              </a:lnSpc>
-              <a:spcBef>
-                <a:spcPts val="0"/>
-              </a:spcBef>
-              <a:spcAft>
-                <a:spcPts val="0"/>
-              </a:spcAft>
-              <a:buNone/>
-            </a:pPr>
-            <a:r>
-              <a:rPr cap="none" sz="1500" i="0" b="0" u="none" strike="noStrike">
-                <a:solidFill>
-                  <a:srgbClr val="16324F">
-                    <a:alpha val="100000"/>
-                  </a:srgbClr>
-                </a:solidFill>
-                <a:latin typeface="Arial"/>
-                <a:cs typeface="Arial"/>
-                <a:ea typeface="Arial"/>
-                <a:sym typeface="Arial"/>
-              </a:rPr>
-              <a:t>Best observed grouped-CV RMSE: 0.537 (elastic_net)</a:t>
-            </a:r>
-          </a:p>
-        </p:txBody>
-      </p:sp>
       <p:sp>
         <p:nvSpPr>
           <p:cNvPr id="5" name=""/>
@@ -9197,9 +9341,58 @@
           </a:p>
         </p:txBody>
       </p:sp>
+      <p:sp>
+        <p:nvSpPr>
+          <p:cNvPr id="3" name=""/>
+          <p:cNvSpPr>
+            <a:spLocks noGrp="1"/>
+          </p:cNvSpPr>
+          <p:nvPr>
+            <p:ph/>
+          </p:nvPr>
+        </p:nvSpPr>
+        <p:spPr>
+          <a:xfrm>
+            <a:off x="594360" y="1024128"/>
+            <a:ext cx="7955280" cy="347472"/>
+          </a:xfrm>
+        </p:spPr>
+        <p:txBody>
+          <a:bodyPr/>
+          <a:lstStyle/>
+          <a:p>
+            <a:pPr algn="l" marL="0" marR="0">
+              <a:lnSpc>
+                <a:spcPct val="100000"/>
+              </a:lnSpc>
+              <a:spcBef>
+                <a:spcPts val="0"/>
+              </a:spcBef>
+              <a:spcAft>
+                <a:spcPts val="0"/>
+              </a:spcAft>
+              <a:buNone/>
+            </a:pPr>
+            <a:r>
+              <a:rPr cap="none" sz="1700" i="0" b="0" u="none" strike="noStrike">
+                <a:solidFill>
+                  <a:srgbClr val="16324F">
+                    <a:alpha val="100000"/>
+                  </a:srgbClr>
+                </a:solidFill>
+                <a:latin typeface="Arial"/>
+                <a:cs typeface="Arial"/>
+                <a:ea typeface="Arial"/>
+                <a:sym typeface="Arial"/>
+              </a:rPr>
+              <a:t>• 360 distinct model/uncertainty combinations; outcomes shown separately</a:t>
+            </a:r>
+          </a:p>
+        </p:txBody>
+      </p:sp>
       <p:pic>
         <p:nvPicPr>
-          <p:cNvPr id="3" name="" descr=""/>
+          <p:cNvPr id="4" name="" descr=""/>
           <p:cNvPicPr>
             <a:picLocks noGrp="1"/>
           </p:cNvPicPr>
@@ -9215,63 +9408,14 @@
         </p:blipFill>
         <p:spPr>
           <a:xfrm>
-            <a:off x="502920" y="1188720"/>
-            <a:ext cx="8138160" cy="4480560"/>
+            <a:off x="502920" y="1847088"/>
+            <a:ext cx="8138160" cy="4160520"/>
           </a:xfrm>
           <a:prstGeom prst="rect">
             <a:avLst/>
           </a:prstGeom>
         </p:spPr>
       </p:pic>
-      <p:sp>
-        <p:nvSpPr>
-          <p:cNvPr id="4" name=""/>
-          <p:cNvSpPr>
-            <a:spLocks noGrp="1"/>
-          </p:cNvSpPr>
-          <p:nvPr>
-            <p:ph/>
-          </p:nvPr>
-        </p:nvSpPr>
-        <p:spPr>
-          <a:xfrm>
-            <a:off x="502920" y="5669280"/>
-            <a:ext cx="8138160" cy="640080"/>
-          </a:xfrm>
-        </p:spPr>
-        <p:txBody>
-          <a:bodyPr/>
-          <a:lstStyle/>
-          <a:p>
-            <a:pPr algn="l" marL="0" marR="0">
-              <a:lnSpc>
-                <a:spcPct val="100000"/>
-              </a:lnSpc>
-              <a:spcBef>
-                <a:spcPts val="0"/>
-              </a:spcBef>
-              <a:spcAft>
-                <a:spcPts val="0"/>
-              </a:spcAft>
-              <a:buNone/>
-            </a:pPr>
-            <a:r>
-              <a:rPr cap="none" sz="1500" i="0" b="0" u="none" strike="noStrike">
-                <a:solidFill>
-                  <a:srgbClr val="16324F">
-                    <a:alpha val="100000"/>
-                  </a:srgbClr>
-                </a:solidFill>
-                <a:latin typeface="Arial"/>
-                <a:cs typeface="Arial"/>
-                <a:ea typeface="Arial"/>
-                <a:sym typeface="Arial"/>
-              </a:rPr>
-              <a:t>360 distinct model/uncertainty combinations; outcomes shown separately</a:t>
-            </a:r>
-          </a:p>
-        </p:txBody>
-      </p:sp>
       <p:sp>
         <p:nvSpPr>
           <p:cNvPr id="5" name=""/>
@@ -11849,9 +11993,58 @@
           </a:p>
         </p:txBody>
       </p:sp>
+      <p:sp>
+        <p:nvSpPr>
+          <p:cNvPr id="3" name=""/>
+          <p:cNvSpPr>
+            <a:spLocks noGrp="1"/>
+          </p:cNvSpPr>
+          <p:nvPr>
+            <p:ph/>
+          </p:nvPr>
+        </p:nvSpPr>
+        <p:spPr>
+          <a:xfrm>
+            <a:off x="594360" y="1024128"/>
+            <a:ext cx="7955280" cy="347472"/>
+          </a:xfrm>
+        </p:spPr>
+        <p:txBody>
+          <a:bodyPr/>
+          <a:lstStyle/>
+          <a:p>
+            <a:pPr algn="l" marL="0" marR="0">
+              <a:lnSpc>
+                <a:spcPct val="100000"/>
+              </a:lnSpc>
+              <a:spcBef>
+                <a:spcPts val="0"/>
+              </a:spcBef>
+              <a:spcAft>
+                <a:spcPts val="0"/>
+              </a:spcAft>
+              <a:buNone/>
+            </a:pPr>
+            <a:r>
+              <a:rPr cap="none" sz="1700" i="0" b="0" u="none" strike="noStrike">
+                <a:solidFill>
+                  <a:srgbClr val="16324F">
+                    <a:alpha val="100000"/>
+                  </a:srgbClr>
+                </a:solidFill>
+                <a:latin typeface="Arial"/>
+                <a:cs typeface="Arial"/>
+                <a:ea typeface="Arial"/>
+                <a:sym typeface="Arial"/>
+              </a:rPr>
+              <a:t>• MCMC diagnostics and model fit answer different questions.</a:t>
+            </a:r>
+          </a:p>
+        </p:txBody>
+      </p:sp>
       <p:pic>
         <p:nvPicPr>
-          <p:cNvPr id="3" name="" descr=""/>
+          <p:cNvPr id="4" name="" descr=""/>
           <p:cNvPicPr>
             <a:picLocks noGrp="1"/>
           </p:cNvPicPr>
@@ -11867,63 +12060,14 @@
         </p:blipFill>
         <p:spPr>
           <a:xfrm>
-            <a:off x="502920" y="1188720"/>
-            <a:ext cx="8138160" cy="4480560"/>
+            <a:off x="502920" y="1847088"/>
+            <a:ext cx="8138160" cy="4160520"/>
           </a:xfrm>
           <a:prstGeom prst="rect">
             <a:avLst/>
           </a:prstGeom>
         </p:spPr>
       </p:pic>
-      <p:sp>
-        <p:nvSpPr>
-          <p:cNvPr id="4" name=""/>
-          <p:cNvSpPr>
-            <a:spLocks noGrp="1"/>
-          </p:cNvSpPr>
-          <p:nvPr>
-            <p:ph/>
-          </p:nvPr>
-        </p:nvSpPr>
-        <p:spPr>
-          <a:xfrm>
-            <a:off x="502920" y="5669280"/>
-            <a:ext cx="8138160" cy="640080"/>
-          </a:xfrm>
-        </p:spPr>
-        <p:txBody>
-          <a:bodyPr/>
-          <a:lstStyle/>
-          <a:p>
-            <a:pPr algn="l" marL="0" marR="0">
-              <a:lnSpc>
-                <a:spcPct val="100000"/>
-              </a:lnSpc>
-              <a:spcBef>
-                <a:spcPts val="0"/>
-              </a:spcBef>
-              <a:spcAft>
-                <a:spcPts val="0"/>
-              </a:spcAft>
-              <a:buNone/>
-            </a:pPr>
-            <a:r>
-              <a:rPr cap="none" sz="1500" i="0" b="0" u="none" strike="noStrike">
-                <a:solidFill>
-                  <a:srgbClr val="16324F">
-                    <a:alpha val="100000"/>
-                  </a:srgbClr>
-                </a:solidFill>
-                <a:latin typeface="Arial"/>
-                <a:cs typeface="Arial"/>
-                <a:ea typeface="Arial"/>
-                <a:sym typeface="Arial"/>
-              </a:rPr>
-              <a:t>MCMC diagnostics and model fit answer different questions.</a:t>
-            </a:r>
-          </a:p>
-        </p:txBody>
-      </p:sp>
       <p:sp>
         <p:nvSpPr>
           <p:cNvPr id="5" name=""/>
@@ -12047,9 +12191,58 @@
           </a:p>
         </p:txBody>
       </p:sp>
+      <p:sp>
+        <p:nvSpPr>
+          <p:cNvPr id="3" name=""/>
+          <p:cNvSpPr>
+            <a:spLocks noGrp="1"/>
+          </p:cNvSpPr>
+          <p:nvPr>
+            <p:ph/>
+          </p:nvPr>
+        </p:nvSpPr>
+        <p:spPr>
+          <a:xfrm>
+            <a:off x="594360" y="1024128"/>
+            <a:ext cx="7955280" cy="347472"/>
+          </a:xfrm>
+        </p:spPr>
+        <p:txBody>
+          <a:bodyPr/>
+          <a:lstStyle/>
+          <a:p>
+            <a:pPr algn="l" marL="0" marR="0">
+              <a:lnSpc>
+                <a:spcPct val="100000"/>
+              </a:lnSpc>
+              <a:spcBef>
+                <a:spcPts val="0"/>
+              </a:spcBef>
+              <a:spcAft>
+                <a:spcPts val="0"/>
+              </a:spcAft>
+              <a:buNone/>
+            </a:pPr>
+            <a:r>
+              <a:rPr cap="none" sz="1700" i="0" b="0" u="none" strike="noStrike">
+                <a:solidFill>
+                  <a:srgbClr val="16324F">
+                    <a:alpha val="100000"/>
+                  </a:srgbClr>
+                </a:solidFill>
+                <a:latin typeface="Arial"/>
+                <a:cs typeface="Arial"/>
+                <a:ea typeface="Arial"/>
+                <a:sym typeface="Arial"/>
+              </a:rPr>
+              <a:t>• Inspect support, balance, clipping, and effective sample size.</a:t>
+            </a:r>
+          </a:p>
+        </p:txBody>
+      </p:sp>
       <p:pic>
         <p:nvPicPr>
-          <p:cNvPr id="3" name="" descr=""/>
+          <p:cNvPr id="4" name="" descr=""/>
           <p:cNvPicPr>
             <a:picLocks noGrp="1"/>
           </p:cNvPicPr>
@@ -12065,63 +12258,14 @@
         </p:blipFill>
         <p:spPr>
           <a:xfrm>
-            <a:off x="502920" y="1188720"/>
-            <a:ext cx="8138160" cy="4480560"/>
+            <a:off x="502920" y="1847088"/>
+            <a:ext cx="8138160" cy="4160520"/>
           </a:xfrm>
           <a:prstGeom prst="rect">
             <a:avLst/>
           </a:prstGeom>
         </p:spPr>
       </p:pic>
-      <p:sp>
-        <p:nvSpPr>
-          <p:cNvPr id="4" name=""/>
-          <p:cNvSpPr>
-            <a:spLocks noGrp="1"/>
-          </p:cNvSpPr>
-          <p:nvPr>
-            <p:ph/>
-          </p:nvPr>
-        </p:nvSpPr>
-        <p:spPr>
-          <a:xfrm>
-            <a:off x="502920" y="5669280"/>
-            <a:ext cx="8138160" cy="640080"/>
-          </a:xfrm>
-        </p:spPr>
-        <p:txBody>
-          <a:bodyPr/>
-          <a:lstStyle/>
-          <a:p>
-            <a:pPr algn="l" marL="0" marR="0">
-              <a:lnSpc>
-                <a:spcPct val="100000"/>
-              </a:lnSpc>
-              <a:spcBef>
-                <a:spcPts val="0"/>
-              </a:spcBef>
-              <a:spcAft>
-                <a:spcPts val="0"/>
-              </a:spcAft>
-              <a:buNone/>
-            </a:pPr>
-            <a:r>
-              <a:rPr cap="none" sz="1500" i="0" b="0" u="none" strike="noStrike">
-                <a:solidFill>
-                  <a:srgbClr val="16324F">
-                    <a:alpha val="100000"/>
-                  </a:srgbClr>
-                </a:solidFill>
-                <a:latin typeface="Arial"/>
-                <a:cs typeface="Arial"/>
-                <a:ea typeface="Arial"/>
-                <a:sym typeface="Arial"/>
-              </a:rPr>
-              <a:t>Inspect support, balance, clipping, and effective sample size.</a:t>
-            </a:r>
-          </a:p>
-        </p:txBody>
-      </p:sp>
       <p:sp>
         <p:nvSpPr>
           <p:cNvPr id="5" name=""/>
@@ -13791,9 +13935,58 @@
           </a:p>
         </p:txBody>
       </p:sp>
+      <p:sp>
+        <p:nvSpPr>
+          <p:cNvPr id="3" name=""/>
+          <p:cNvSpPr>
+            <a:spLocks noGrp="1"/>
+          </p:cNvSpPr>
+          <p:nvPr>
+            <p:ph/>
+          </p:nvPr>
+        </p:nvSpPr>
+        <p:spPr>
+          <a:xfrm>
+            <a:off x="594360" y="1024128"/>
+            <a:ext cx="7955280" cy="347472"/>
+          </a:xfrm>
+        </p:spPr>
+        <p:txBody>
+          <a:bodyPr/>
+          <a:lstStyle/>
+          <a:p>
+            <a:pPr algn="l" marL="0" marR="0">
+              <a:lnSpc>
+                <a:spcPct val="100000"/>
+              </a:lnSpc>
+              <a:spcBef>
+                <a:spcPts val="0"/>
+              </a:spcBef>
+              <a:spcAft>
+                <a:spcPts val="0"/>
+              </a:spcAft>
+              <a:buNone/>
+            </a:pPr>
+            <a:r>
+              <a:rPr cap="none" sz="1700" i="0" b="0" u="none" strike="noStrike">
+                <a:solidFill>
+                  <a:srgbClr val="16324F">
+                    <a:alpha val="100000"/>
+                  </a:srgbClr>
+                </a:solidFill>
+                <a:latin typeface="Arial"/>
+                <a:cs typeface="Arial"/>
+                <a:ea typeface="Arial"/>
+                <a:sym typeface="Arial"/>
+              </a:rPr>
+              <a:t>• County adjustment is essential context, not causal identification.</a:t>
+            </a:r>
+          </a:p>
+        </p:txBody>
+      </p:sp>
       <p:pic>
         <p:nvPicPr>
-          <p:cNvPr id="3" name="" descr=""/>
+          <p:cNvPr id="4" name="" descr=""/>
           <p:cNvPicPr>
             <a:picLocks noGrp="1"/>
           </p:cNvPicPr>
@@ -13809,63 +14002,14 @@
         </p:blipFill>
         <p:spPr>
           <a:xfrm>
-            <a:off x="502920" y="1188720"/>
-            <a:ext cx="8138160" cy="4480560"/>
+            <a:off x="502920" y="1847088"/>
+            <a:ext cx="8138160" cy="4160520"/>
           </a:xfrm>
           <a:prstGeom prst="rect">
             <a:avLst/>
           </a:prstGeom>
         </p:spPr>
       </p:pic>
-      <p:sp>
-        <p:nvSpPr>
-          <p:cNvPr id="4" name=""/>
-          <p:cNvSpPr>
-            <a:spLocks noGrp="1"/>
-          </p:cNvSpPr>
-          <p:nvPr>
-            <p:ph/>
-          </p:nvPr>
-        </p:nvSpPr>
-        <p:spPr>
-          <a:xfrm>
-            <a:off x="502920" y="5669280"/>
-            <a:ext cx="8138160" cy="640080"/>
-          </a:xfrm>
-        </p:spPr>
-        <p:txBody>
-          <a:bodyPr/>
-          <a:lstStyle/>
-          <a:p>
-            <a:pPr algn="l" marL="0" marR="0">
-              <a:lnSpc>
-                <a:spcPct val="100000"/>
-              </a:lnSpc>
-              <a:spcBef>
-                <a:spcPts val="0"/>
-              </a:spcBef>
-              <a:spcAft>
-                <a:spcPts val="0"/>
-              </a:spcAft>
-              <a:buNone/>
-            </a:pPr>
-            <a:r>
-              <a:rPr cap="none" sz="1500" i="0" b="0" u="none" strike="noStrike">
-                <a:solidFill>
-                  <a:srgbClr val="16324F">
-                    <a:alpha val="100000"/>
-                  </a:srgbClr>
-                </a:solidFill>
-                <a:latin typeface="Arial"/>
-                <a:cs typeface="Arial"/>
-                <a:ea typeface="Arial"/>
-                <a:sym typeface="Arial"/>
-              </a:rPr>
-              <a:t>County adjustment is essential context, not causal identification.</a:t>
-            </a:r>
-          </a:p>
-        </p:txBody>
-      </p:sp>
       <p:sp>
         <p:nvSpPr>
           <p:cNvPr id="5" name=""/>
@@ -13989,9 +14133,58 @@
           </a:p>
         </p:txBody>
       </p:sp>
+      <p:sp>
+        <p:nvSpPr>
+          <p:cNvPr id="3" name=""/>
+          <p:cNvSpPr>
+            <a:spLocks noGrp="1"/>
+          </p:cNvSpPr>
+          <p:nvPr>
+            <p:ph/>
+          </p:nvPr>
+        </p:nvSpPr>
+        <p:spPr>
+          <a:xfrm>
+            <a:off x="594360" y="1024128"/>
+            <a:ext cx="7955280" cy="347472"/>
+          </a:xfrm>
+        </p:spPr>
+        <p:txBody>
+          <a:bodyPr/>
+          <a:lstStyle/>
+          <a:p>
+            <a:pPr algn="l" marL="0" marR="0">
+              <a:lnSpc>
+                <a:spcPct val="100000"/>
+              </a:lnSpc>
+              <a:spcBef>
+                <a:spcPts val="0"/>
+              </a:spcBef>
+              <a:spcAft>
+                <a:spcPts val="0"/>
+              </a:spcAft>
+              <a:buNone/>
+            </a:pPr>
+            <a:r>
+              <a:rPr cap="none" sz="1700" i="0" b="0" u="none" strike="noStrike">
+                <a:solidFill>
+                  <a:srgbClr val="16324F">
+                    <a:alpha val="100000"/>
+                  </a:srgbClr>
+                </a:solidFill>
+                <a:latin typeface="Arial"/>
+                <a:cs typeface="Arial"/>
+                <a:ea typeface="Arial"/>
+                <a:sym typeface="Arial"/>
+              </a:rPr>
+              <a:t>• Non-lethal management; population control; safety; accepting damage</a:t>
+            </a:r>
+          </a:p>
+        </p:txBody>
+      </p:sp>
       <p:pic>
         <p:nvPicPr>
-          <p:cNvPr id="3" name="" descr=""/>
+          <p:cNvPr id="4" name="" descr=""/>
           <p:cNvPicPr>
             <a:picLocks noGrp="1"/>
           </p:cNvPicPr>
@@ -14007,63 +14200,14 @@
         </p:blipFill>
         <p:spPr>
           <a:xfrm>
-            <a:off x="502920" y="1188720"/>
-            <a:ext cx="8138160" cy="4480560"/>
+            <a:off x="502920" y="1847088"/>
+            <a:ext cx="8138160" cy="4160520"/>
           </a:xfrm>
           <a:prstGeom prst="rect">
             <a:avLst/>
           </a:prstGeom>
         </p:spPr>
       </p:pic>
-      <p:sp>
-        <p:nvSpPr>
-          <p:cNvPr id="4" name=""/>
-          <p:cNvSpPr>
-            <a:spLocks noGrp="1"/>
-          </p:cNvSpPr>
-          <p:nvPr>
-            <p:ph/>
-          </p:nvPr>
-        </p:nvSpPr>
-        <p:spPr>
-          <a:xfrm>
-            <a:off x="502920" y="5669280"/>
-            <a:ext cx="8138160" cy="640080"/>
-          </a:xfrm>
-        </p:spPr>
-        <p:txBody>
-          <a:bodyPr/>
-          <a:lstStyle/>
-          <a:p>
-            <a:pPr algn="l" marL="0" marR="0">
-              <a:lnSpc>
-                <a:spcPct val="100000"/>
-              </a:lnSpc>
-              <a:spcBef>
-                <a:spcPts val="0"/>
-              </a:spcBef>
-              <a:spcAft>
-                <a:spcPts val="0"/>
-              </a:spcAft>
-              <a:buNone/>
-            </a:pPr>
-            <a:r>
-              <a:rPr cap="none" sz="1500" i="0" b="0" u="none" strike="noStrike">
-                <a:solidFill>
-                  <a:srgbClr val="16324F">
-                    <a:alpha val="100000"/>
-                  </a:srgbClr>
-                </a:solidFill>
-                <a:latin typeface="Arial"/>
-                <a:cs typeface="Arial"/>
-                <a:ea typeface="Arial"/>
-                <a:sym typeface="Arial"/>
-              </a:rPr>
-              <a:t>Non-lethal management; population control; safety; accepting damage</a:t>
-            </a:r>
-          </a:p>
-        </p:txBody>
-      </p:sp>
       <p:sp>
         <p:nvSpPr>
           <p:cNvPr id="5" name=""/>
@@ -14457,9 +14601,107 @@
           </a:p>
         </p:txBody>
       </p:sp>
+      <p:sp>
+        <p:nvSpPr>
+          <p:cNvPr id="3" name=""/>
+          <p:cNvSpPr>
+            <a:spLocks noGrp="1"/>
+          </p:cNvSpPr>
+          <p:nvPr>
+            <p:ph/>
+          </p:nvPr>
+        </p:nvSpPr>
+        <p:spPr>
+          <a:xfrm>
+            <a:off x="594360" y="1024128"/>
+            <a:ext cx="7955280" cy="347472"/>
+          </a:xfrm>
+        </p:spPr>
+        <p:txBody>
+          <a:bodyPr/>
+          <a:lstStyle/>
+          <a:p>
+            <a:pPr algn="l" marL="0" marR="0">
+              <a:lnSpc>
+                <a:spcPct val="100000"/>
+              </a:lnSpc>
+              <a:spcBef>
+                <a:spcPts val="0"/>
+              </a:spcBef>
+              <a:spcAft>
+                <a:spcPts val="0"/>
+              </a:spcAft>
+              <a:buNone/>
+            </a:pPr>
+            <a:r>
+              <a:rPr cap="none" sz="1700" i="0" b="0" u="none" strike="noStrike">
+                <a:solidFill>
+                  <a:srgbClr val="16324F">
+                    <a:alpha val="100000"/>
+                  </a:srgbClr>
+                </a:solidFill>
+                <a:latin typeface="Arial"/>
+                <a:cs typeface="Arial"/>
+                <a:ea typeface="Arial"/>
+                <a:sym typeface="Arial"/>
+              </a:rPr>
+              <a:t>• Profiles, missingness, skewness, ceiling effects, and imbalance</a:t>
+            </a:r>
+          </a:p>
+        </p:txBody>
+      </p:sp>
+      <p:sp>
+        <p:nvSpPr>
+          <p:cNvPr id="4" name=""/>
+          <p:cNvSpPr>
+            <a:spLocks noGrp="1"/>
+          </p:cNvSpPr>
+          <p:nvPr>
+            <p:ph/>
+          </p:nvPr>
+        </p:nvSpPr>
+        <p:spPr>
+          <a:xfrm>
+            <a:off x="594360" y="1408176"/>
+            <a:ext cx="7955280" cy="347472"/>
+          </a:xfrm>
+        </p:spPr>
+        <p:txBody>
+          <a:bodyPr/>
+          <a:lstStyle/>
+          <a:p>
+            <a:pPr algn="l" marL="0" marR="0">
+              <a:lnSpc>
+                <a:spcPct val="100000"/>
+              </a:lnSpc>
+              <a:spcBef>
+                <a:spcPts val="0"/>
+              </a:spcBef>
+              <a:spcAft>
+                <a:spcPts val="0"/>
+              </a:spcAft>
+              <a:buNone/>
+            </a:pPr>
+            <a:r>
+              <a:rPr cap="none" sz="1700" i="0" b="0" u="none" strike="noStrike">
+                <a:solidFill>
+                  <a:srgbClr val="16324F">
+                    <a:alpha val="100000"/>
+                  </a:srgbClr>
+                </a:solidFill>
+                <a:latin typeface="Arial"/>
+                <a:cs typeface="Arial"/>
+                <a:ea typeface="Arial"/>
+                <a:sym typeface="Arial"/>
+              </a:rPr>
+              <a:t>• Raw questionnaire fields retain additional substantive information</a:t>
+            </a:r>
+          </a:p>
+        </p:txBody>
+      </p:sp>
       <p:pic>
         <p:nvPicPr>
-          <p:cNvPr id="3" name="" descr=""/>
+          <p:cNvPr id="5" name="" descr=""/>
           <p:cNvPicPr>
             <a:picLocks noGrp="1"/>
           </p:cNvPicPr>
@@ -14475,8 +14717,8 @@
         </p:blipFill>
         <p:spPr>
           <a:xfrm>
-            <a:off x="502920" y="1188720"/>
-            <a:ext cx="8138160" cy="4480560"/>
+            <a:off x="502920" y="1847088"/>
+            <a:ext cx="8138160" cy="4160520"/>
           </a:xfrm>
           <a:prstGeom prst="rect">
             <a:avLst/>
@@ -14485,57 +14727,7 @@
       </p:pic>
       <p:sp>
         <p:nvSpPr>
-          <p:cNvPr id="4" name=""/>
-          <p:cNvSpPr>
-            <a:spLocks noGrp="1"/>
-          </p:cNvSpPr>
-          <p:nvPr>
-            <p:ph/>
-          </p:nvPr>
-        </p:nvSpPr>
-        <p:spPr>
-          <a:xfrm>
-            <a:off x="502920" y="5669280"/>
-            <a:ext cx="8138160" cy="640080"/>
-          </a:xfrm>
-        </p:spPr>
-        <p:txBody>
-          <a:bodyPr/>
-          <a:lstStyle/>
-          <a:p>
-            <a:pPr algn="l" marL="0" marR="0">
-              <a:lnSpc>
-                <a:spcPct val="100000"/>
-              </a:lnSpc>
-              <a:spcBef>
-                <a:spcPts val="0"/>
-              </a:spcBef>
-              <a:spcAft>
-                <a:spcPts val="0"/>
-              </a:spcAft>
-              <a:buNone/>
-            </a:pPr>
-            <a:r>
-              <a:rPr cap="none" sz="1500" i="0" b="0" u="none" strike="noStrike">
-                <a:solidFill>
-                  <a:srgbClr val="16324F">
-                    <a:alpha val="100000"/>
-                  </a:srgbClr>
-                </a:solidFill>
-                <a:latin typeface="Arial"/>
-                <a:cs typeface="Arial"/>
-                <a:ea typeface="Arial"/>
-                <a:sym typeface="Arial"/>
-              </a:rPr>
-              <a:t>Profiles, missingness, skewness, ceiling effects, and imbalance
-Raw questionnaire fields retain additional substantive information</a:t>
-            </a:r>
-          </a:p>
-        </p:txBody>
-      </p:sp>
-      <p:sp>
-        <p:nvSpPr>
-          <p:cNvPr id="5" name=""/>
+          <p:cNvPr id="6" name=""/>
           <p:cNvSpPr>
             <a:spLocks noGrp="1"/>
           </p:cNvSpPr>

</xml_diff>

<commit_message>
remove presentation footers and update date
</commit_message>
<xml_diff>
--- a/results/fresh/presentation/Wildboar_Consulting_Presentation.pptx
+++ b/results/fresh/presentation/Wildboar_Consulting_Presentation.pptx
@@ -4668,55 +4668,6 @@
           </a:p>
         </p:txBody>
       </p:sp>
-      <p:sp>
-        <p:nvSpPr>
-          <p:cNvPr id="6" name=""/>
-          <p:cNvSpPr>
-            <a:spLocks noGrp="1"/>
-          </p:cNvSpPr>
-          <p:nvPr>
-            <p:ph/>
-          </p:nvPr>
-        </p:nvSpPr>
-        <p:spPr>
-          <a:xfrm>
-            <a:off x="457200" y="6510528"/>
-            <a:ext cx="8229600" cy="182880"/>
-          </a:xfrm>
-        </p:spPr>
-        <p:txBody>
-          <a:bodyPr/>
-          <a:lstStyle/>
-          <a:p>
-            <a:pPr algn="l" marL="0" marR="0">
-              <a:lnSpc>
-                <a:spcPct val="100000"/>
-              </a:lnSpc>
-              <a:spcBef>
-                <a:spcPts val="0"/>
-              </a:spcBef>
-              <a:spcAft>
-                <a:spcPts val="0"/>
-              </a:spcAft>
-              <a:buNone/>
-            </a:pPr>
-            <a:r>
-              <a:rPr cap="none" sz="900" i="0" b="0" u="none" strike="noStrike">
-                <a:solidFill>
-                  <a:srgbClr val="64748B">
-                    <a:alpha val="100000"/>
-                  </a:srgbClr>
-                </a:solidFill>
-                <a:latin typeface="Arial"/>
-                <a:cs typeface="Arial"/>
-                <a:ea typeface="Arial"/>
-                <a:sym typeface="Arial"/>
-              </a:rPr>
-              <a:t>PRESENTATION RELEASE • 17 SEPT 2026  |  1</a:t>
-            </a:r>
-          </a:p>
-        </p:txBody>
-      </p:sp>
     </p:spTree>
   </p:cSld>
   <p:clrMapOvr>
@@ -4987,55 +4938,6 @@
           </a:p>
         </p:txBody>
       </p:sp>
-      <p:sp>
-        <p:nvSpPr>
-          <p:cNvPr id="7" name=""/>
-          <p:cNvSpPr>
-            <a:spLocks noGrp="1"/>
-          </p:cNvSpPr>
-          <p:nvPr>
-            <p:ph/>
-          </p:nvPr>
-        </p:nvSpPr>
-        <p:spPr>
-          <a:xfrm>
-            <a:off x="457200" y="6510528"/>
-            <a:ext cx="8229600" cy="182880"/>
-          </a:xfrm>
-        </p:spPr>
-        <p:txBody>
-          <a:bodyPr/>
-          <a:lstStyle/>
-          <a:p>
-            <a:pPr algn="l" marL="0" marR="0">
-              <a:lnSpc>
-                <a:spcPct val="100000"/>
-              </a:lnSpc>
-              <a:spcBef>
-                <a:spcPts val="0"/>
-              </a:spcBef>
-              <a:spcAft>
-                <a:spcPts val="0"/>
-              </a:spcAft>
-              <a:buNone/>
-            </a:pPr>
-            <a:r>
-              <a:rPr cap="none" sz="900" i="0" b="0" u="none" strike="noStrike">
-                <a:solidFill>
-                  <a:srgbClr val="64748B">
-                    <a:alpha val="100000"/>
-                  </a:srgbClr>
-                </a:solidFill>
-                <a:latin typeface="Arial"/>
-                <a:cs typeface="Arial"/>
-                <a:ea typeface="Arial"/>
-                <a:sym typeface="Arial"/>
-              </a:rPr>
-              <a:t>PRESENTATION RELEASE • 17 SEPT 2026  |  10</a:t>
-            </a:r>
-          </a:p>
-        </p:txBody>
-      </p:sp>
     </p:spTree>
   </p:cSld>
   <p:clrMapOvr>
@@ -5234,55 +5136,6 @@
           </a:prstGeom>
         </p:spPr>
       </p:pic>
-      <p:sp>
-        <p:nvSpPr>
-          <p:cNvPr id="6" name=""/>
-          <p:cNvSpPr>
-            <a:spLocks noGrp="1"/>
-          </p:cNvSpPr>
-          <p:nvPr>
-            <p:ph/>
-          </p:nvPr>
-        </p:nvSpPr>
-        <p:spPr>
-          <a:xfrm>
-            <a:off x="457200" y="6510528"/>
-            <a:ext cx="8229600" cy="182880"/>
-          </a:xfrm>
-        </p:spPr>
-        <p:txBody>
-          <a:bodyPr/>
-          <a:lstStyle/>
-          <a:p>
-            <a:pPr algn="l" marL="0" marR="0">
-              <a:lnSpc>
-                <a:spcPct val="100000"/>
-              </a:lnSpc>
-              <a:spcBef>
-                <a:spcPts val="0"/>
-              </a:spcBef>
-              <a:spcAft>
-                <a:spcPts val="0"/>
-              </a:spcAft>
-              <a:buNone/>
-            </a:pPr>
-            <a:r>
-              <a:rPr cap="none" sz="900" i="0" b="0" u="none" strike="noStrike">
-                <a:solidFill>
-                  <a:srgbClr val="64748B">
-                    <a:alpha val="100000"/>
-                  </a:srgbClr>
-                </a:solidFill>
-                <a:latin typeface="Arial"/>
-                <a:cs typeface="Arial"/>
-                <a:ea typeface="Arial"/>
-                <a:sym typeface="Arial"/>
-              </a:rPr>
-              <a:t>PRESENTATION RELEASE • 17 SEPT 2026  |  11</a:t>
-            </a:r>
-          </a:p>
-        </p:txBody>
-      </p:sp>
     </p:spTree>
   </p:cSld>
   <p:clrMapOvr>
@@ -5504,55 +5357,6 @@
           </a:p>
         </p:txBody>
       </p:sp>
-      <p:sp>
-        <p:nvSpPr>
-          <p:cNvPr id="6" name=""/>
-          <p:cNvSpPr>
-            <a:spLocks noGrp="1"/>
-          </p:cNvSpPr>
-          <p:nvPr>
-            <p:ph/>
-          </p:nvPr>
-        </p:nvSpPr>
-        <p:spPr>
-          <a:xfrm>
-            <a:off x="457200" y="6510528"/>
-            <a:ext cx="8229600" cy="182880"/>
-          </a:xfrm>
-        </p:spPr>
-        <p:txBody>
-          <a:bodyPr/>
-          <a:lstStyle/>
-          <a:p>
-            <a:pPr algn="l" marL="0" marR="0">
-              <a:lnSpc>
-                <a:spcPct val="100000"/>
-              </a:lnSpc>
-              <a:spcBef>
-                <a:spcPts val="0"/>
-              </a:spcBef>
-              <a:spcAft>
-                <a:spcPts val="0"/>
-              </a:spcAft>
-              <a:buNone/>
-            </a:pPr>
-            <a:r>
-              <a:rPr cap="none" sz="900" i="0" b="0" u="none" strike="noStrike">
-                <a:solidFill>
-                  <a:srgbClr val="64748B">
-                    <a:alpha val="100000"/>
-                  </a:srgbClr>
-                </a:solidFill>
-                <a:latin typeface="Arial"/>
-                <a:cs typeface="Arial"/>
-                <a:ea typeface="Arial"/>
-                <a:sym typeface="Arial"/>
-              </a:rPr>
-              <a:t>PRESENTATION RELEASE • 17 SEPT 2026  |  12</a:t>
-            </a:r>
-          </a:p>
-        </p:txBody>
-      </p:sp>
     </p:spTree>
   </p:cSld>
   <p:clrMapOvr>
@@ -5800,55 +5604,6 @@
           </a:prstGeom>
         </p:spPr>
       </p:pic>
-      <p:sp>
-        <p:nvSpPr>
-          <p:cNvPr id="7" name=""/>
-          <p:cNvSpPr>
-            <a:spLocks noGrp="1"/>
-          </p:cNvSpPr>
-          <p:nvPr>
-            <p:ph/>
-          </p:nvPr>
-        </p:nvSpPr>
-        <p:spPr>
-          <a:xfrm>
-            <a:off x="457200" y="6510528"/>
-            <a:ext cx="8229600" cy="182880"/>
-          </a:xfrm>
-        </p:spPr>
-        <p:txBody>
-          <a:bodyPr/>
-          <a:lstStyle/>
-          <a:p>
-            <a:pPr algn="l" marL="0" marR="0">
-              <a:lnSpc>
-                <a:spcPct val="100000"/>
-              </a:lnSpc>
-              <a:spcBef>
-                <a:spcPts val="0"/>
-              </a:spcBef>
-              <a:spcAft>
-                <a:spcPts val="0"/>
-              </a:spcAft>
-              <a:buNone/>
-            </a:pPr>
-            <a:r>
-              <a:rPr cap="none" sz="900" i="0" b="0" u="none" strike="noStrike">
-                <a:solidFill>
-                  <a:srgbClr val="64748B">
-                    <a:alpha val="100000"/>
-                  </a:srgbClr>
-                </a:solidFill>
-                <a:latin typeface="Arial"/>
-                <a:cs typeface="Arial"/>
-                <a:ea typeface="Arial"/>
-                <a:sym typeface="Arial"/>
-              </a:rPr>
-              <a:t>PRESENTATION RELEASE • 17 SEPT 2026  |  13</a:t>
-            </a:r>
-          </a:p>
-        </p:txBody>
-      </p:sp>
     </p:spTree>
   </p:cSld>
   <p:clrMapOvr>
@@ -6070,55 +5825,6 @@
           </a:p>
         </p:txBody>
       </p:sp>
-      <p:sp>
-        <p:nvSpPr>
-          <p:cNvPr id="6" name=""/>
-          <p:cNvSpPr>
-            <a:spLocks noGrp="1"/>
-          </p:cNvSpPr>
-          <p:nvPr>
-            <p:ph/>
-          </p:nvPr>
-        </p:nvSpPr>
-        <p:spPr>
-          <a:xfrm>
-            <a:off x="457200" y="6510528"/>
-            <a:ext cx="8229600" cy="182880"/>
-          </a:xfrm>
-        </p:spPr>
-        <p:txBody>
-          <a:bodyPr/>
-          <a:lstStyle/>
-          <a:p>
-            <a:pPr algn="l" marL="0" marR="0">
-              <a:lnSpc>
-                <a:spcPct val="100000"/>
-              </a:lnSpc>
-              <a:spcBef>
-                <a:spcPts val="0"/>
-              </a:spcBef>
-              <a:spcAft>
-                <a:spcPts val="0"/>
-              </a:spcAft>
-              <a:buNone/>
-            </a:pPr>
-            <a:r>
-              <a:rPr cap="none" sz="900" i="0" b="0" u="none" strike="noStrike">
-                <a:solidFill>
-                  <a:srgbClr val="64748B">
-                    <a:alpha val="100000"/>
-                  </a:srgbClr>
-                </a:solidFill>
-                <a:latin typeface="Arial"/>
-                <a:cs typeface="Arial"/>
-                <a:ea typeface="Arial"/>
-                <a:sym typeface="Arial"/>
-              </a:rPr>
-              <a:t>PRESENTATION RELEASE • 17 SEPT 2026  |  14</a:t>
-            </a:r>
-          </a:p>
-        </p:txBody>
-      </p:sp>
     </p:spTree>
   </p:cSld>
   <p:clrMapOvr>
@@ -6389,55 +6095,6 @@
           </a:p>
         </p:txBody>
       </p:sp>
-      <p:sp>
-        <p:nvSpPr>
-          <p:cNvPr id="7" name=""/>
-          <p:cNvSpPr>
-            <a:spLocks noGrp="1"/>
-          </p:cNvSpPr>
-          <p:nvPr>
-            <p:ph/>
-          </p:nvPr>
-        </p:nvSpPr>
-        <p:spPr>
-          <a:xfrm>
-            <a:off x="457200" y="6510528"/>
-            <a:ext cx="8229600" cy="182880"/>
-          </a:xfrm>
-        </p:spPr>
-        <p:txBody>
-          <a:bodyPr/>
-          <a:lstStyle/>
-          <a:p>
-            <a:pPr algn="l" marL="0" marR="0">
-              <a:lnSpc>
-                <a:spcPct val="100000"/>
-              </a:lnSpc>
-              <a:spcBef>
-                <a:spcPts val="0"/>
-              </a:spcBef>
-              <a:spcAft>
-                <a:spcPts val="0"/>
-              </a:spcAft>
-              <a:buNone/>
-            </a:pPr>
-            <a:r>
-              <a:rPr cap="none" sz="900" i="0" b="0" u="none" strike="noStrike">
-                <a:solidFill>
-                  <a:srgbClr val="64748B">
-                    <a:alpha val="100000"/>
-                  </a:srgbClr>
-                </a:solidFill>
-                <a:latin typeface="Arial"/>
-                <a:cs typeface="Arial"/>
-                <a:ea typeface="Arial"/>
-                <a:sym typeface="Arial"/>
-              </a:rPr>
-              <a:t>PRESENTATION RELEASE • 17 SEPT 2026  |  15</a:t>
-            </a:r>
-          </a:p>
-        </p:txBody>
-      </p:sp>
     </p:spTree>
   </p:cSld>
   <p:clrMapOvr>
@@ -6587,55 +6244,6 @@
           </a:prstGeom>
         </p:spPr>
       </p:pic>
-      <p:sp>
-        <p:nvSpPr>
-          <p:cNvPr id="5" name=""/>
-          <p:cNvSpPr>
-            <a:spLocks noGrp="1"/>
-          </p:cNvSpPr>
-          <p:nvPr>
-            <p:ph/>
-          </p:nvPr>
-        </p:nvSpPr>
-        <p:spPr>
-          <a:xfrm>
-            <a:off x="457200" y="6510528"/>
-            <a:ext cx="8229600" cy="182880"/>
-          </a:xfrm>
-        </p:spPr>
-        <p:txBody>
-          <a:bodyPr/>
-          <a:lstStyle/>
-          <a:p>
-            <a:pPr algn="l" marL="0" marR="0">
-              <a:lnSpc>
-                <a:spcPct val="100000"/>
-              </a:lnSpc>
-              <a:spcBef>
-                <a:spcPts val="0"/>
-              </a:spcBef>
-              <a:spcAft>
-                <a:spcPts val="0"/>
-              </a:spcAft>
-              <a:buNone/>
-            </a:pPr>
-            <a:r>
-              <a:rPr cap="none" sz="900" i="0" b="0" u="none" strike="noStrike">
-                <a:solidFill>
-                  <a:srgbClr val="64748B">
-                    <a:alpha val="100000"/>
-                  </a:srgbClr>
-                </a:solidFill>
-                <a:latin typeface="Arial"/>
-                <a:cs typeface="Arial"/>
-                <a:ea typeface="Arial"/>
-                <a:sym typeface="Arial"/>
-              </a:rPr>
-              <a:t>PRESENTATION RELEASE • 17 SEPT 2026  |  16</a:t>
-            </a:r>
-          </a:p>
-        </p:txBody>
-      </p:sp>
     </p:spTree>
   </p:cSld>
   <p:clrMapOvr>
@@ -6785,55 +6393,6 @@
           </a:prstGeom>
         </p:spPr>
       </p:pic>
-      <p:sp>
-        <p:nvSpPr>
-          <p:cNvPr id="5" name=""/>
-          <p:cNvSpPr>
-            <a:spLocks noGrp="1"/>
-          </p:cNvSpPr>
-          <p:nvPr>
-            <p:ph/>
-          </p:nvPr>
-        </p:nvSpPr>
-        <p:spPr>
-          <a:xfrm>
-            <a:off x="457200" y="6510528"/>
-            <a:ext cx="8229600" cy="182880"/>
-          </a:xfrm>
-        </p:spPr>
-        <p:txBody>
-          <a:bodyPr/>
-          <a:lstStyle/>
-          <a:p>
-            <a:pPr algn="l" marL="0" marR="0">
-              <a:lnSpc>
-                <a:spcPct val="100000"/>
-              </a:lnSpc>
-              <a:spcBef>
-                <a:spcPts val="0"/>
-              </a:spcBef>
-              <a:spcAft>
-                <a:spcPts val="0"/>
-              </a:spcAft>
-              <a:buNone/>
-            </a:pPr>
-            <a:r>
-              <a:rPr cap="none" sz="900" i="0" b="0" u="none" strike="noStrike">
-                <a:solidFill>
-                  <a:srgbClr val="64748B">
-                    <a:alpha val="100000"/>
-                  </a:srgbClr>
-                </a:solidFill>
-                <a:latin typeface="Arial"/>
-                <a:cs typeface="Arial"/>
-                <a:ea typeface="Arial"/>
-                <a:sym typeface="Arial"/>
-              </a:rPr>
-              <a:t>PRESENTATION RELEASE • 17 SEPT 2026  |  17</a:t>
-            </a:r>
-          </a:p>
-        </p:txBody>
-      </p:sp>
     </p:spTree>
   </p:cSld>
   <p:clrMapOvr>
@@ -7055,55 +6614,6 @@
           </a:p>
         </p:txBody>
       </p:sp>
-      <p:sp>
-        <p:nvSpPr>
-          <p:cNvPr id="6" name=""/>
-          <p:cNvSpPr>
-            <a:spLocks noGrp="1"/>
-          </p:cNvSpPr>
-          <p:nvPr>
-            <p:ph/>
-          </p:nvPr>
-        </p:nvSpPr>
-        <p:spPr>
-          <a:xfrm>
-            <a:off x="457200" y="6510528"/>
-            <a:ext cx="8229600" cy="182880"/>
-          </a:xfrm>
-        </p:spPr>
-        <p:txBody>
-          <a:bodyPr/>
-          <a:lstStyle/>
-          <a:p>
-            <a:pPr algn="l" marL="0" marR="0">
-              <a:lnSpc>
-                <a:spcPct val="100000"/>
-              </a:lnSpc>
-              <a:spcBef>
-                <a:spcPts val="0"/>
-              </a:spcBef>
-              <a:spcAft>
-                <a:spcPts val="0"/>
-              </a:spcAft>
-              <a:buNone/>
-            </a:pPr>
-            <a:r>
-              <a:rPr cap="none" sz="900" i="0" b="0" u="none" strike="noStrike">
-                <a:solidFill>
-                  <a:srgbClr val="64748B">
-                    <a:alpha val="100000"/>
-                  </a:srgbClr>
-                </a:solidFill>
-                <a:latin typeface="Arial"/>
-                <a:cs typeface="Arial"/>
-                <a:ea typeface="Arial"/>
-                <a:sym typeface="Arial"/>
-              </a:rPr>
-              <a:t>PRESENTATION RELEASE • 17 SEPT 2026  |  18</a:t>
-            </a:r>
-          </a:p>
-        </p:txBody>
-      </p:sp>
     </p:spTree>
   </p:cSld>
   <p:clrMapOvr>
@@ -7325,55 +6835,6 @@
           </a:p>
         </p:txBody>
       </p:sp>
-      <p:sp>
-        <p:nvSpPr>
-          <p:cNvPr id="6" name=""/>
-          <p:cNvSpPr>
-            <a:spLocks noGrp="1"/>
-          </p:cNvSpPr>
-          <p:nvPr>
-            <p:ph/>
-          </p:nvPr>
-        </p:nvSpPr>
-        <p:spPr>
-          <a:xfrm>
-            <a:off x="457200" y="6510528"/>
-            <a:ext cx="8229600" cy="182880"/>
-          </a:xfrm>
-        </p:spPr>
-        <p:txBody>
-          <a:bodyPr/>
-          <a:lstStyle/>
-          <a:p>
-            <a:pPr algn="l" marL="0" marR="0">
-              <a:lnSpc>
-                <a:spcPct val="100000"/>
-              </a:lnSpc>
-              <a:spcBef>
-                <a:spcPts val="0"/>
-              </a:spcBef>
-              <a:spcAft>
-                <a:spcPts val="0"/>
-              </a:spcAft>
-              <a:buNone/>
-            </a:pPr>
-            <a:r>
-              <a:rPr cap="none" sz="900" i="0" b="0" u="none" strike="noStrike">
-                <a:solidFill>
-                  <a:srgbClr val="64748B">
-                    <a:alpha val="100000"/>
-                  </a:srgbClr>
-                </a:solidFill>
-                <a:latin typeface="Arial"/>
-                <a:cs typeface="Arial"/>
-                <a:ea typeface="Arial"/>
-                <a:sym typeface="Arial"/>
-              </a:rPr>
-              <a:t>PRESENTATION RELEASE • 17 SEPT 2026  |  19</a:t>
-            </a:r>
-          </a:p>
-        </p:txBody>
-      </p:sp>
     </p:spTree>
   </p:cSld>
   <p:clrMapOvr>
@@ -7595,55 +7056,6 @@
           </a:p>
         </p:txBody>
       </p:sp>
-      <p:sp>
-        <p:nvSpPr>
-          <p:cNvPr id="6" name=""/>
-          <p:cNvSpPr>
-            <a:spLocks noGrp="1"/>
-          </p:cNvSpPr>
-          <p:nvPr>
-            <p:ph/>
-          </p:nvPr>
-        </p:nvSpPr>
-        <p:spPr>
-          <a:xfrm>
-            <a:off x="457200" y="6510528"/>
-            <a:ext cx="8229600" cy="182880"/>
-          </a:xfrm>
-        </p:spPr>
-        <p:txBody>
-          <a:bodyPr/>
-          <a:lstStyle/>
-          <a:p>
-            <a:pPr algn="l" marL="0" marR="0">
-              <a:lnSpc>
-                <a:spcPct val="100000"/>
-              </a:lnSpc>
-              <a:spcBef>
-                <a:spcPts val="0"/>
-              </a:spcBef>
-              <a:spcAft>
-                <a:spcPts val="0"/>
-              </a:spcAft>
-              <a:buNone/>
-            </a:pPr>
-            <a:r>
-              <a:rPr cap="none" sz="900" i="0" b="0" u="none" strike="noStrike">
-                <a:solidFill>
-                  <a:srgbClr val="64748B">
-                    <a:alpha val="100000"/>
-                  </a:srgbClr>
-                </a:solidFill>
-                <a:latin typeface="Arial"/>
-                <a:cs typeface="Arial"/>
-                <a:ea typeface="Arial"/>
-                <a:sym typeface="Arial"/>
-              </a:rPr>
-              <a:t>PRESENTATION RELEASE • 17 SEPT 2026  |  2</a:t>
-            </a:r>
-          </a:p>
-        </p:txBody>
-      </p:sp>
     </p:spTree>
   </p:cSld>
   <p:clrMapOvr>
@@ -7793,55 +7205,6 @@
           </a:prstGeom>
         </p:spPr>
       </p:pic>
-      <p:sp>
-        <p:nvSpPr>
-          <p:cNvPr id="5" name=""/>
-          <p:cNvSpPr>
-            <a:spLocks noGrp="1"/>
-          </p:cNvSpPr>
-          <p:nvPr>
-            <p:ph/>
-          </p:nvPr>
-        </p:nvSpPr>
-        <p:spPr>
-          <a:xfrm>
-            <a:off x="457200" y="6510528"/>
-            <a:ext cx="8229600" cy="182880"/>
-          </a:xfrm>
-        </p:spPr>
-        <p:txBody>
-          <a:bodyPr/>
-          <a:lstStyle/>
-          <a:p>
-            <a:pPr algn="l" marL="0" marR="0">
-              <a:lnSpc>
-                <a:spcPct val="100000"/>
-              </a:lnSpc>
-              <a:spcBef>
-                <a:spcPts val="0"/>
-              </a:spcBef>
-              <a:spcAft>
-                <a:spcPts val="0"/>
-              </a:spcAft>
-              <a:buNone/>
-            </a:pPr>
-            <a:r>
-              <a:rPr cap="none" sz="900" i="0" b="0" u="none" strike="noStrike">
-                <a:solidFill>
-                  <a:srgbClr val="64748B">
-                    <a:alpha val="100000"/>
-                  </a:srgbClr>
-                </a:solidFill>
-                <a:latin typeface="Arial"/>
-                <a:cs typeface="Arial"/>
-                <a:ea typeface="Arial"/>
-                <a:sym typeface="Arial"/>
-              </a:rPr>
-              <a:t>PRESENTATION RELEASE • 17 SEPT 2026  |  20</a:t>
-            </a:r>
-          </a:p>
-        </p:txBody>
-      </p:sp>
     </p:spTree>
   </p:cSld>
   <p:clrMapOvr>
@@ -8112,55 +7475,6 @@
           </a:p>
         </p:txBody>
       </p:sp>
-      <p:sp>
-        <p:nvSpPr>
-          <p:cNvPr id="7" name=""/>
-          <p:cNvSpPr>
-            <a:spLocks noGrp="1"/>
-          </p:cNvSpPr>
-          <p:nvPr>
-            <p:ph/>
-          </p:nvPr>
-        </p:nvSpPr>
-        <p:spPr>
-          <a:xfrm>
-            <a:off x="457200" y="6510528"/>
-            <a:ext cx="8229600" cy="182880"/>
-          </a:xfrm>
-        </p:spPr>
-        <p:txBody>
-          <a:bodyPr/>
-          <a:lstStyle/>
-          <a:p>
-            <a:pPr algn="l" marL="0" marR="0">
-              <a:lnSpc>
-                <a:spcPct val="100000"/>
-              </a:lnSpc>
-              <a:spcBef>
-                <a:spcPts val="0"/>
-              </a:spcBef>
-              <a:spcAft>
-                <a:spcPts val="0"/>
-              </a:spcAft>
-              <a:buNone/>
-            </a:pPr>
-            <a:r>
-              <a:rPr cap="none" sz="900" i="0" b="0" u="none" strike="noStrike">
-                <a:solidFill>
-                  <a:srgbClr val="64748B">
-                    <a:alpha val="100000"/>
-                  </a:srgbClr>
-                </a:solidFill>
-                <a:latin typeface="Arial"/>
-                <a:cs typeface="Arial"/>
-                <a:ea typeface="Arial"/>
-                <a:sym typeface="Arial"/>
-              </a:rPr>
-              <a:t>PRESENTATION RELEASE • 17 SEPT 2026  |  21</a:t>
-            </a:r>
-          </a:p>
-        </p:txBody>
-      </p:sp>
     </p:spTree>
   </p:cSld>
   <p:clrMapOvr>
@@ -8431,55 +7745,6 @@
           </a:p>
         </p:txBody>
       </p:sp>
-      <p:sp>
-        <p:nvSpPr>
-          <p:cNvPr id="7" name=""/>
-          <p:cNvSpPr>
-            <a:spLocks noGrp="1"/>
-          </p:cNvSpPr>
-          <p:nvPr>
-            <p:ph/>
-          </p:nvPr>
-        </p:nvSpPr>
-        <p:spPr>
-          <a:xfrm>
-            <a:off x="457200" y="6510528"/>
-            <a:ext cx="8229600" cy="182880"/>
-          </a:xfrm>
-        </p:spPr>
-        <p:txBody>
-          <a:bodyPr/>
-          <a:lstStyle/>
-          <a:p>
-            <a:pPr algn="l" marL="0" marR="0">
-              <a:lnSpc>
-                <a:spcPct val="100000"/>
-              </a:lnSpc>
-              <a:spcBef>
-                <a:spcPts val="0"/>
-              </a:spcBef>
-              <a:spcAft>
-                <a:spcPts val="0"/>
-              </a:spcAft>
-              <a:buNone/>
-            </a:pPr>
-            <a:r>
-              <a:rPr cap="none" sz="900" i="0" b="0" u="none" strike="noStrike">
-                <a:solidFill>
-                  <a:srgbClr val="64748B">
-                    <a:alpha val="100000"/>
-                  </a:srgbClr>
-                </a:solidFill>
-                <a:latin typeface="Arial"/>
-                <a:cs typeface="Arial"/>
-                <a:ea typeface="Arial"/>
-                <a:sym typeface="Arial"/>
-              </a:rPr>
-              <a:t>PRESENTATION RELEASE • 17 SEPT 2026  |  22</a:t>
-            </a:r>
-          </a:p>
-        </p:txBody>
-      </p:sp>
     </p:spTree>
   </p:cSld>
   <p:clrMapOvr>
@@ -8750,55 +8015,6 @@
           </a:p>
         </p:txBody>
       </p:sp>
-      <p:sp>
-        <p:nvSpPr>
-          <p:cNvPr id="7" name=""/>
-          <p:cNvSpPr>
-            <a:spLocks noGrp="1"/>
-          </p:cNvSpPr>
-          <p:nvPr>
-            <p:ph/>
-          </p:nvPr>
-        </p:nvSpPr>
-        <p:spPr>
-          <a:xfrm>
-            <a:off x="457200" y="6510528"/>
-            <a:ext cx="8229600" cy="182880"/>
-          </a:xfrm>
-        </p:spPr>
-        <p:txBody>
-          <a:bodyPr/>
-          <a:lstStyle/>
-          <a:p>
-            <a:pPr algn="l" marL="0" marR="0">
-              <a:lnSpc>
-                <a:spcPct val="100000"/>
-              </a:lnSpc>
-              <a:spcBef>
-                <a:spcPts val="0"/>
-              </a:spcBef>
-              <a:spcAft>
-                <a:spcPts val="0"/>
-              </a:spcAft>
-              <a:buNone/>
-            </a:pPr>
-            <a:r>
-              <a:rPr cap="none" sz="900" i="0" b="0" u="none" strike="noStrike">
-                <a:solidFill>
-                  <a:srgbClr val="64748B">
-                    <a:alpha val="100000"/>
-                  </a:srgbClr>
-                </a:solidFill>
-                <a:latin typeface="Arial"/>
-                <a:cs typeface="Arial"/>
-                <a:ea typeface="Arial"/>
-                <a:sym typeface="Arial"/>
-              </a:rPr>
-              <a:t>PRESENTATION RELEASE • 17 SEPT 2026  |  23</a:t>
-            </a:r>
-          </a:p>
-        </p:txBody>
-      </p:sp>
     </p:spTree>
   </p:cSld>
   <p:clrMapOvr>
@@ -8948,55 +8164,6 @@
           </a:prstGeom>
         </p:spPr>
       </p:pic>
-      <p:sp>
-        <p:nvSpPr>
-          <p:cNvPr id="5" name=""/>
-          <p:cNvSpPr>
-            <a:spLocks noGrp="1"/>
-          </p:cNvSpPr>
-          <p:nvPr>
-            <p:ph/>
-          </p:nvPr>
-        </p:nvSpPr>
-        <p:spPr>
-          <a:xfrm>
-            <a:off x="457200" y="6510528"/>
-            <a:ext cx="8229600" cy="182880"/>
-          </a:xfrm>
-        </p:spPr>
-        <p:txBody>
-          <a:bodyPr/>
-          <a:lstStyle/>
-          <a:p>
-            <a:pPr algn="l" marL="0" marR="0">
-              <a:lnSpc>
-                <a:spcPct val="100000"/>
-              </a:lnSpc>
-              <a:spcBef>
-                <a:spcPts val="0"/>
-              </a:spcBef>
-              <a:spcAft>
-                <a:spcPts val="0"/>
-              </a:spcAft>
-              <a:buNone/>
-            </a:pPr>
-            <a:r>
-              <a:rPr cap="none" sz="900" i="0" b="0" u="none" strike="noStrike">
-                <a:solidFill>
-                  <a:srgbClr val="64748B">
-                    <a:alpha val="100000"/>
-                  </a:srgbClr>
-                </a:solidFill>
-                <a:latin typeface="Arial"/>
-                <a:cs typeface="Arial"/>
-                <a:ea typeface="Arial"/>
-                <a:sym typeface="Arial"/>
-              </a:rPr>
-              <a:t>PRESENTATION RELEASE • 17 SEPT 2026  |  24</a:t>
-            </a:r>
-          </a:p>
-        </p:txBody>
-      </p:sp>
     </p:spTree>
   </p:cSld>
   <p:clrMapOvr>
@@ -9218,55 +8385,6 @@
           </a:p>
         </p:txBody>
       </p:sp>
-      <p:sp>
-        <p:nvSpPr>
-          <p:cNvPr id="6" name=""/>
-          <p:cNvSpPr>
-            <a:spLocks noGrp="1"/>
-          </p:cNvSpPr>
-          <p:nvPr>
-            <p:ph/>
-          </p:nvPr>
-        </p:nvSpPr>
-        <p:spPr>
-          <a:xfrm>
-            <a:off x="457200" y="6510528"/>
-            <a:ext cx="8229600" cy="182880"/>
-          </a:xfrm>
-        </p:spPr>
-        <p:txBody>
-          <a:bodyPr/>
-          <a:lstStyle/>
-          <a:p>
-            <a:pPr algn="l" marL="0" marR="0">
-              <a:lnSpc>
-                <a:spcPct val="100000"/>
-              </a:lnSpc>
-              <a:spcBef>
-                <a:spcPts val="0"/>
-              </a:spcBef>
-              <a:spcAft>
-                <a:spcPts val="0"/>
-              </a:spcAft>
-              <a:buNone/>
-            </a:pPr>
-            <a:r>
-              <a:rPr cap="none" sz="900" i="0" b="0" u="none" strike="noStrike">
-                <a:solidFill>
-                  <a:srgbClr val="64748B">
-                    <a:alpha val="100000"/>
-                  </a:srgbClr>
-                </a:solidFill>
-                <a:latin typeface="Arial"/>
-                <a:cs typeface="Arial"/>
-                <a:ea typeface="Arial"/>
-                <a:sym typeface="Arial"/>
-              </a:rPr>
-              <a:t>PRESENTATION RELEASE • 17 SEPT 2026  |  25</a:t>
-            </a:r>
-          </a:p>
-        </p:txBody>
-      </p:sp>
     </p:spTree>
   </p:cSld>
   <p:clrMapOvr>
@@ -9416,55 +8534,6 @@
           </a:prstGeom>
         </p:spPr>
       </p:pic>
-      <p:sp>
-        <p:nvSpPr>
-          <p:cNvPr id="5" name=""/>
-          <p:cNvSpPr>
-            <a:spLocks noGrp="1"/>
-          </p:cNvSpPr>
-          <p:nvPr>
-            <p:ph/>
-          </p:nvPr>
-        </p:nvSpPr>
-        <p:spPr>
-          <a:xfrm>
-            <a:off x="457200" y="6510528"/>
-            <a:ext cx="8229600" cy="182880"/>
-          </a:xfrm>
-        </p:spPr>
-        <p:txBody>
-          <a:bodyPr/>
-          <a:lstStyle/>
-          <a:p>
-            <a:pPr algn="l" marL="0" marR="0">
-              <a:lnSpc>
-                <a:spcPct val="100000"/>
-              </a:lnSpc>
-              <a:spcBef>
-                <a:spcPts val="0"/>
-              </a:spcBef>
-              <a:spcAft>
-                <a:spcPts val="0"/>
-              </a:spcAft>
-              <a:buNone/>
-            </a:pPr>
-            <a:r>
-              <a:rPr cap="none" sz="900" i="0" b="0" u="none" strike="noStrike">
-                <a:solidFill>
-                  <a:srgbClr val="64748B">
-                    <a:alpha val="100000"/>
-                  </a:srgbClr>
-                </a:solidFill>
-                <a:latin typeface="Arial"/>
-                <a:cs typeface="Arial"/>
-                <a:ea typeface="Arial"/>
-                <a:sym typeface="Arial"/>
-              </a:rPr>
-              <a:t>PRESENTATION RELEASE • 17 SEPT 2026  |  26</a:t>
-            </a:r>
-          </a:p>
-        </p:txBody>
-      </p:sp>
     </p:spTree>
   </p:cSld>
   <p:clrMapOvr>
@@ -9735,55 +8804,6 @@
           </a:p>
         </p:txBody>
       </p:sp>
-      <p:sp>
-        <p:nvSpPr>
-          <p:cNvPr id="7" name=""/>
-          <p:cNvSpPr>
-            <a:spLocks noGrp="1"/>
-          </p:cNvSpPr>
-          <p:nvPr>
-            <p:ph/>
-          </p:nvPr>
-        </p:nvSpPr>
-        <p:spPr>
-          <a:xfrm>
-            <a:off x="457200" y="6510528"/>
-            <a:ext cx="8229600" cy="182880"/>
-          </a:xfrm>
-        </p:spPr>
-        <p:txBody>
-          <a:bodyPr/>
-          <a:lstStyle/>
-          <a:p>
-            <a:pPr algn="l" marL="0" marR="0">
-              <a:lnSpc>
-                <a:spcPct val="100000"/>
-              </a:lnSpc>
-              <a:spcBef>
-                <a:spcPts val="0"/>
-              </a:spcBef>
-              <a:spcAft>
-                <a:spcPts val="0"/>
-              </a:spcAft>
-              <a:buNone/>
-            </a:pPr>
-            <a:r>
-              <a:rPr cap="none" sz="900" i="0" b="0" u="none" strike="noStrike">
-                <a:solidFill>
-                  <a:srgbClr val="64748B">
-                    <a:alpha val="100000"/>
-                  </a:srgbClr>
-                </a:solidFill>
-                <a:latin typeface="Arial"/>
-                <a:cs typeface="Arial"/>
-                <a:ea typeface="Arial"/>
-                <a:sym typeface="Arial"/>
-              </a:rPr>
-              <a:t>PRESENTATION RELEASE • 17 SEPT 2026  |  27</a:t>
-            </a:r>
-          </a:p>
-        </p:txBody>
-      </p:sp>
     </p:spTree>
   </p:cSld>
   <p:clrMapOvr>
@@ -10054,55 +9074,6 @@
           </a:p>
         </p:txBody>
       </p:sp>
-      <p:sp>
-        <p:nvSpPr>
-          <p:cNvPr id="7" name=""/>
-          <p:cNvSpPr>
-            <a:spLocks noGrp="1"/>
-          </p:cNvSpPr>
-          <p:nvPr>
-            <p:ph/>
-          </p:nvPr>
-        </p:nvSpPr>
-        <p:spPr>
-          <a:xfrm>
-            <a:off x="457200" y="6510528"/>
-            <a:ext cx="8229600" cy="182880"/>
-          </a:xfrm>
-        </p:spPr>
-        <p:txBody>
-          <a:bodyPr/>
-          <a:lstStyle/>
-          <a:p>
-            <a:pPr algn="l" marL="0" marR="0">
-              <a:lnSpc>
-                <a:spcPct val="100000"/>
-              </a:lnSpc>
-              <a:spcBef>
-                <a:spcPts val="0"/>
-              </a:spcBef>
-              <a:spcAft>
-                <a:spcPts val="0"/>
-              </a:spcAft>
-              <a:buNone/>
-            </a:pPr>
-            <a:r>
-              <a:rPr cap="none" sz="900" i="0" b="0" u="none" strike="noStrike">
-                <a:solidFill>
-                  <a:srgbClr val="64748B">
-                    <a:alpha val="100000"/>
-                  </a:srgbClr>
-                </a:solidFill>
-                <a:latin typeface="Arial"/>
-                <a:cs typeface="Arial"/>
-                <a:ea typeface="Arial"/>
-                <a:sym typeface="Arial"/>
-              </a:rPr>
-              <a:t>PRESENTATION RELEASE • 17 SEPT 2026  |  28</a:t>
-            </a:r>
-          </a:p>
-        </p:txBody>
-      </p:sp>
     </p:spTree>
   </p:cSld>
   <p:clrMapOvr>
@@ -10373,55 +9344,6 @@
           </a:p>
         </p:txBody>
       </p:sp>
-      <p:sp>
-        <p:nvSpPr>
-          <p:cNvPr id="7" name=""/>
-          <p:cNvSpPr>
-            <a:spLocks noGrp="1"/>
-          </p:cNvSpPr>
-          <p:nvPr>
-            <p:ph/>
-          </p:nvPr>
-        </p:nvSpPr>
-        <p:spPr>
-          <a:xfrm>
-            <a:off x="457200" y="6510528"/>
-            <a:ext cx="8229600" cy="182880"/>
-          </a:xfrm>
-        </p:spPr>
-        <p:txBody>
-          <a:bodyPr/>
-          <a:lstStyle/>
-          <a:p>
-            <a:pPr algn="l" marL="0" marR="0">
-              <a:lnSpc>
-                <a:spcPct val="100000"/>
-              </a:lnSpc>
-              <a:spcBef>
-                <a:spcPts val="0"/>
-              </a:spcBef>
-              <a:spcAft>
-                <a:spcPts val="0"/>
-              </a:spcAft>
-              <a:buNone/>
-            </a:pPr>
-            <a:r>
-              <a:rPr cap="none" sz="900" i="0" b="0" u="none" strike="noStrike">
-                <a:solidFill>
-                  <a:srgbClr val="64748B">
-                    <a:alpha val="100000"/>
-                  </a:srgbClr>
-                </a:solidFill>
-                <a:latin typeface="Arial"/>
-                <a:cs typeface="Arial"/>
-                <a:ea typeface="Arial"/>
-                <a:sym typeface="Arial"/>
-              </a:rPr>
-              <a:t>PRESENTATION RELEASE • 17 SEPT 2026  |  29</a:t>
-            </a:r>
-          </a:p>
-        </p:txBody>
-      </p:sp>
     </p:spTree>
   </p:cSld>
   <p:clrMapOvr>
@@ -10643,55 +9565,6 @@
           </a:p>
         </p:txBody>
       </p:sp>
-      <p:sp>
-        <p:nvSpPr>
-          <p:cNvPr id="6" name=""/>
-          <p:cNvSpPr>
-            <a:spLocks noGrp="1"/>
-          </p:cNvSpPr>
-          <p:nvPr>
-            <p:ph/>
-          </p:nvPr>
-        </p:nvSpPr>
-        <p:spPr>
-          <a:xfrm>
-            <a:off x="457200" y="6510528"/>
-            <a:ext cx="8229600" cy="182880"/>
-          </a:xfrm>
-        </p:spPr>
-        <p:txBody>
-          <a:bodyPr/>
-          <a:lstStyle/>
-          <a:p>
-            <a:pPr algn="l" marL="0" marR="0">
-              <a:lnSpc>
-                <a:spcPct val="100000"/>
-              </a:lnSpc>
-              <a:spcBef>
-                <a:spcPts val="0"/>
-              </a:spcBef>
-              <a:spcAft>
-                <a:spcPts val="0"/>
-              </a:spcAft>
-              <a:buNone/>
-            </a:pPr>
-            <a:r>
-              <a:rPr cap="none" sz="900" i="0" b="0" u="none" strike="noStrike">
-                <a:solidFill>
-                  <a:srgbClr val="64748B">
-                    <a:alpha val="100000"/>
-                  </a:srgbClr>
-                </a:solidFill>
-                <a:latin typeface="Arial"/>
-                <a:cs typeface="Arial"/>
-                <a:ea typeface="Arial"/>
-                <a:sym typeface="Arial"/>
-              </a:rPr>
-              <a:t>PRESENTATION RELEASE • 17 SEPT 2026  |  3</a:t>
-            </a:r>
-          </a:p>
-        </p:txBody>
-      </p:sp>
     </p:spTree>
   </p:cSld>
   <p:clrMapOvr>
@@ -10913,55 +9786,6 @@
           </a:p>
         </p:txBody>
       </p:sp>
-      <p:sp>
-        <p:nvSpPr>
-          <p:cNvPr id="6" name=""/>
-          <p:cNvSpPr>
-            <a:spLocks noGrp="1"/>
-          </p:cNvSpPr>
-          <p:nvPr>
-            <p:ph/>
-          </p:nvPr>
-        </p:nvSpPr>
-        <p:spPr>
-          <a:xfrm>
-            <a:off x="457200" y="6510528"/>
-            <a:ext cx="8229600" cy="182880"/>
-          </a:xfrm>
-        </p:spPr>
-        <p:txBody>
-          <a:bodyPr/>
-          <a:lstStyle/>
-          <a:p>
-            <a:pPr algn="l" marL="0" marR="0">
-              <a:lnSpc>
-                <a:spcPct val="100000"/>
-              </a:lnSpc>
-              <a:spcBef>
-                <a:spcPts val="0"/>
-              </a:spcBef>
-              <a:spcAft>
-                <a:spcPts val="0"/>
-              </a:spcAft>
-              <a:buNone/>
-            </a:pPr>
-            <a:r>
-              <a:rPr cap="none" sz="900" i="0" b="0" u="none" strike="noStrike">
-                <a:solidFill>
-                  <a:srgbClr val="64748B">
-                    <a:alpha val="100000"/>
-                  </a:srgbClr>
-                </a:solidFill>
-                <a:latin typeface="Arial"/>
-                <a:cs typeface="Arial"/>
-                <a:ea typeface="Arial"/>
-                <a:sym typeface="Arial"/>
-              </a:rPr>
-              <a:t>PRESENTATION RELEASE • 17 SEPT 2026  |  30</a:t>
-            </a:r>
-          </a:p>
-        </p:txBody>
-      </p:sp>
     </p:spTree>
   </p:cSld>
   <p:clrMapOvr>
@@ -11232,55 +10056,6 @@
           </a:p>
         </p:txBody>
       </p:sp>
-      <p:sp>
-        <p:nvSpPr>
-          <p:cNvPr id="7" name=""/>
-          <p:cNvSpPr>
-            <a:spLocks noGrp="1"/>
-          </p:cNvSpPr>
-          <p:nvPr>
-            <p:ph/>
-          </p:nvPr>
-        </p:nvSpPr>
-        <p:spPr>
-          <a:xfrm>
-            <a:off x="457200" y="6510528"/>
-            <a:ext cx="8229600" cy="182880"/>
-          </a:xfrm>
-        </p:spPr>
-        <p:txBody>
-          <a:bodyPr/>
-          <a:lstStyle/>
-          <a:p>
-            <a:pPr algn="l" marL="0" marR="0">
-              <a:lnSpc>
-                <a:spcPct val="100000"/>
-              </a:lnSpc>
-              <a:spcBef>
-                <a:spcPts val="0"/>
-              </a:spcBef>
-              <a:spcAft>
-                <a:spcPts val="0"/>
-              </a:spcAft>
-              <a:buNone/>
-            </a:pPr>
-            <a:r>
-              <a:rPr cap="none" sz="900" i="0" b="0" u="none" strike="noStrike">
-                <a:solidFill>
-                  <a:srgbClr val="64748B">
-                    <a:alpha val="100000"/>
-                  </a:srgbClr>
-                </a:solidFill>
-                <a:latin typeface="Arial"/>
-                <a:cs typeface="Arial"/>
-                <a:ea typeface="Arial"/>
-                <a:sym typeface="Arial"/>
-              </a:rPr>
-              <a:t>DISCUSSION BACKUP  |  31</a:t>
-            </a:r>
-          </a:p>
-        </p:txBody>
-      </p:sp>
     </p:spTree>
   </p:cSld>
   <p:clrMapOvr>
@@ -11551,55 +10326,6 @@
           </a:p>
         </p:txBody>
       </p:sp>
-      <p:sp>
-        <p:nvSpPr>
-          <p:cNvPr id="7" name=""/>
-          <p:cNvSpPr>
-            <a:spLocks noGrp="1"/>
-          </p:cNvSpPr>
-          <p:nvPr>
-            <p:ph/>
-          </p:nvPr>
-        </p:nvSpPr>
-        <p:spPr>
-          <a:xfrm>
-            <a:off x="457200" y="6510528"/>
-            <a:ext cx="8229600" cy="182880"/>
-          </a:xfrm>
-        </p:spPr>
-        <p:txBody>
-          <a:bodyPr/>
-          <a:lstStyle/>
-          <a:p>
-            <a:pPr algn="l" marL="0" marR="0">
-              <a:lnSpc>
-                <a:spcPct val="100000"/>
-              </a:lnSpc>
-              <a:spcBef>
-                <a:spcPts val="0"/>
-              </a:spcBef>
-              <a:spcAft>
-                <a:spcPts val="0"/>
-              </a:spcAft>
-              <a:buNone/>
-            </a:pPr>
-            <a:r>
-              <a:rPr cap="none" sz="900" i="0" b="0" u="none" strike="noStrike">
-                <a:solidFill>
-                  <a:srgbClr val="64748B">
-                    <a:alpha val="100000"/>
-                  </a:srgbClr>
-                </a:solidFill>
-                <a:latin typeface="Arial"/>
-                <a:cs typeface="Arial"/>
-                <a:ea typeface="Arial"/>
-                <a:sym typeface="Arial"/>
-              </a:rPr>
-              <a:t>DISCUSSION BACKUP  |  32</a:t>
-            </a:r>
-          </a:p>
-        </p:txBody>
-      </p:sp>
     </p:spTree>
   </p:cSld>
   <p:clrMapOvr>
@@ -11870,55 +10596,6 @@
           </a:p>
         </p:txBody>
       </p:sp>
-      <p:sp>
-        <p:nvSpPr>
-          <p:cNvPr id="7" name=""/>
-          <p:cNvSpPr>
-            <a:spLocks noGrp="1"/>
-          </p:cNvSpPr>
-          <p:nvPr>
-            <p:ph/>
-          </p:nvPr>
-        </p:nvSpPr>
-        <p:spPr>
-          <a:xfrm>
-            <a:off x="457200" y="6510528"/>
-            <a:ext cx="8229600" cy="182880"/>
-          </a:xfrm>
-        </p:spPr>
-        <p:txBody>
-          <a:bodyPr/>
-          <a:lstStyle/>
-          <a:p>
-            <a:pPr algn="l" marL="0" marR="0">
-              <a:lnSpc>
-                <a:spcPct val="100000"/>
-              </a:lnSpc>
-              <a:spcBef>
-                <a:spcPts val="0"/>
-              </a:spcBef>
-              <a:spcAft>
-                <a:spcPts val="0"/>
-              </a:spcAft>
-              <a:buNone/>
-            </a:pPr>
-            <a:r>
-              <a:rPr cap="none" sz="900" i="0" b="0" u="none" strike="noStrike">
-                <a:solidFill>
-                  <a:srgbClr val="64748B">
-                    <a:alpha val="100000"/>
-                  </a:srgbClr>
-                </a:solidFill>
-                <a:latin typeface="Arial"/>
-                <a:cs typeface="Arial"/>
-                <a:ea typeface="Arial"/>
-                <a:sym typeface="Arial"/>
-              </a:rPr>
-              <a:t>DISCUSSION BACKUP  |  33</a:t>
-            </a:r>
-          </a:p>
-        </p:txBody>
-      </p:sp>
     </p:spTree>
   </p:cSld>
   <p:clrMapOvr>
@@ -12068,55 +10745,6 @@
           </a:prstGeom>
         </p:spPr>
       </p:pic>
-      <p:sp>
-        <p:nvSpPr>
-          <p:cNvPr id="5" name=""/>
-          <p:cNvSpPr>
-            <a:spLocks noGrp="1"/>
-          </p:cNvSpPr>
-          <p:nvPr>
-            <p:ph/>
-          </p:nvPr>
-        </p:nvSpPr>
-        <p:spPr>
-          <a:xfrm>
-            <a:off x="457200" y="6510528"/>
-            <a:ext cx="8229600" cy="182880"/>
-          </a:xfrm>
-        </p:spPr>
-        <p:txBody>
-          <a:bodyPr/>
-          <a:lstStyle/>
-          <a:p>
-            <a:pPr algn="l" marL="0" marR="0">
-              <a:lnSpc>
-                <a:spcPct val="100000"/>
-              </a:lnSpc>
-              <a:spcBef>
-                <a:spcPts val="0"/>
-              </a:spcBef>
-              <a:spcAft>
-                <a:spcPts val="0"/>
-              </a:spcAft>
-              <a:buNone/>
-            </a:pPr>
-            <a:r>
-              <a:rPr cap="none" sz="900" i="0" b="0" u="none" strike="noStrike">
-                <a:solidFill>
-                  <a:srgbClr val="64748B">
-                    <a:alpha val="100000"/>
-                  </a:srgbClr>
-                </a:solidFill>
-                <a:latin typeface="Arial"/>
-                <a:cs typeface="Arial"/>
-                <a:ea typeface="Arial"/>
-                <a:sym typeface="Arial"/>
-              </a:rPr>
-              <a:t>DISCUSSION BACKUP  |  34</a:t>
-            </a:r>
-          </a:p>
-        </p:txBody>
-      </p:sp>
     </p:spTree>
   </p:cSld>
   <p:clrMapOvr>
@@ -12266,55 +10894,6 @@
           </a:prstGeom>
         </p:spPr>
       </p:pic>
-      <p:sp>
-        <p:nvSpPr>
-          <p:cNvPr id="5" name=""/>
-          <p:cNvSpPr>
-            <a:spLocks noGrp="1"/>
-          </p:cNvSpPr>
-          <p:nvPr>
-            <p:ph/>
-          </p:nvPr>
-        </p:nvSpPr>
-        <p:spPr>
-          <a:xfrm>
-            <a:off x="457200" y="6510528"/>
-            <a:ext cx="8229600" cy="182880"/>
-          </a:xfrm>
-        </p:spPr>
-        <p:txBody>
-          <a:bodyPr/>
-          <a:lstStyle/>
-          <a:p>
-            <a:pPr algn="l" marL="0" marR="0">
-              <a:lnSpc>
-                <a:spcPct val="100000"/>
-              </a:lnSpc>
-              <a:spcBef>
-                <a:spcPts val="0"/>
-              </a:spcBef>
-              <a:spcAft>
-                <a:spcPts val="0"/>
-              </a:spcAft>
-              <a:buNone/>
-            </a:pPr>
-            <a:r>
-              <a:rPr cap="none" sz="900" i="0" b="0" u="none" strike="noStrike">
-                <a:solidFill>
-                  <a:srgbClr val="64748B">
-                    <a:alpha val="100000"/>
-                  </a:srgbClr>
-                </a:solidFill>
-                <a:latin typeface="Arial"/>
-                <a:cs typeface="Arial"/>
-                <a:ea typeface="Arial"/>
-                <a:sym typeface="Arial"/>
-              </a:rPr>
-              <a:t>DISCUSSION BACKUP  |  35</a:t>
-            </a:r>
-          </a:p>
-        </p:txBody>
-      </p:sp>
     </p:spTree>
   </p:cSld>
   <p:clrMapOvr>
@@ -12585,55 +11164,6 @@
           </a:p>
         </p:txBody>
       </p:sp>
-      <p:sp>
-        <p:nvSpPr>
-          <p:cNvPr id="7" name=""/>
-          <p:cNvSpPr>
-            <a:spLocks noGrp="1"/>
-          </p:cNvSpPr>
-          <p:nvPr>
-            <p:ph/>
-          </p:nvPr>
-        </p:nvSpPr>
-        <p:spPr>
-          <a:xfrm>
-            <a:off x="457200" y="6510528"/>
-            <a:ext cx="8229600" cy="182880"/>
-          </a:xfrm>
-        </p:spPr>
-        <p:txBody>
-          <a:bodyPr/>
-          <a:lstStyle/>
-          <a:p>
-            <a:pPr algn="l" marL="0" marR="0">
-              <a:lnSpc>
-                <a:spcPct val="100000"/>
-              </a:lnSpc>
-              <a:spcBef>
-                <a:spcPts val="0"/>
-              </a:spcBef>
-              <a:spcAft>
-                <a:spcPts val="0"/>
-              </a:spcAft>
-              <a:buNone/>
-            </a:pPr>
-            <a:r>
-              <a:rPr cap="none" sz="900" i="0" b="0" u="none" strike="noStrike">
-                <a:solidFill>
-                  <a:srgbClr val="64748B">
-                    <a:alpha val="100000"/>
-                  </a:srgbClr>
-                </a:solidFill>
-                <a:latin typeface="Arial"/>
-                <a:cs typeface="Arial"/>
-                <a:ea typeface="Arial"/>
-                <a:sym typeface="Arial"/>
-              </a:rPr>
-              <a:t>DISCUSSION BACKUP  |  36</a:t>
-            </a:r>
-          </a:p>
-        </p:txBody>
-      </p:sp>
     </p:spTree>
   </p:cSld>
   <p:clrMapOvr>
@@ -12904,55 +11434,6 @@
           </a:p>
         </p:txBody>
       </p:sp>
-      <p:sp>
-        <p:nvSpPr>
-          <p:cNvPr id="7" name=""/>
-          <p:cNvSpPr>
-            <a:spLocks noGrp="1"/>
-          </p:cNvSpPr>
-          <p:nvPr>
-            <p:ph/>
-          </p:nvPr>
-        </p:nvSpPr>
-        <p:spPr>
-          <a:xfrm>
-            <a:off x="457200" y="6510528"/>
-            <a:ext cx="8229600" cy="182880"/>
-          </a:xfrm>
-        </p:spPr>
-        <p:txBody>
-          <a:bodyPr/>
-          <a:lstStyle/>
-          <a:p>
-            <a:pPr algn="l" marL="0" marR="0">
-              <a:lnSpc>
-                <a:spcPct val="100000"/>
-              </a:lnSpc>
-              <a:spcBef>
-                <a:spcPts val="0"/>
-              </a:spcBef>
-              <a:spcAft>
-                <a:spcPts val="0"/>
-              </a:spcAft>
-              <a:buNone/>
-            </a:pPr>
-            <a:r>
-              <a:rPr cap="none" sz="900" i="0" b="0" u="none" strike="noStrike">
-                <a:solidFill>
-                  <a:srgbClr val="64748B">
-                    <a:alpha val="100000"/>
-                  </a:srgbClr>
-                </a:solidFill>
-                <a:latin typeface="Arial"/>
-                <a:cs typeface="Arial"/>
-                <a:ea typeface="Arial"/>
-                <a:sym typeface="Arial"/>
-              </a:rPr>
-              <a:t>DISCUSSION BACKUP  |  37</a:t>
-            </a:r>
-          </a:p>
-        </p:txBody>
-      </p:sp>
     </p:spTree>
   </p:cSld>
   <p:clrMapOvr>
@@ -13223,55 +11704,6 @@
           </a:p>
         </p:txBody>
       </p:sp>
-      <p:sp>
-        <p:nvSpPr>
-          <p:cNvPr id="7" name=""/>
-          <p:cNvSpPr>
-            <a:spLocks noGrp="1"/>
-          </p:cNvSpPr>
-          <p:nvPr>
-            <p:ph/>
-          </p:nvPr>
-        </p:nvSpPr>
-        <p:spPr>
-          <a:xfrm>
-            <a:off x="457200" y="6510528"/>
-            <a:ext cx="8229600" cy="182880"/>
-          </a:xfrm>
-        </p:spPr>
-        <p:txBody>
-          <a:bodyPr/>
-          <a:lstStyle/>
-          <a:p>
-            <a:pPr algn="l" marL="0" marR="0">
-              <a:lnSpc>
-                <a:spcPct val="100000"/>
-              </a:lnSpc>
-              <a:spcBef>
-                <a:spcPts val="0"/>
-              </a:spcBef>
-              <a:spcAft>
-                <a:spcPts val="0"/>
-              </a:spcAft>
-              <a:buNone/>
-            </a:pPr>
-            <a:r>
-              <a:rPr cap="none" sz="900" i="0" b="0" u="none" strike="noStrike">
-                <a:solidFill>
-                  <a:srgbClr val="64748B">
-                    <a:alpha val="100000"/>
-                  </a:srgbClr>
-                </a:solidFill>
-                <a:latin typeface="Arial"/>
-                <a:cs typeface="Arial"/>
-                <a:ea typeface="Arial"/>
-                <a:sym typeface="Arial"/>
-              </a:rPr>
-              <a:t>DISCUSSION BACKUP  |  38</a:t>
-            </a:r>
-          </a:p>
-        </p:txBody>
-      </p:sp>
     </p:spTree>
   </p:cSld>
   <p:clrMapOvr>
@@ -13542,55 +11974,6 @@
           </a:p>
         </p:txBody>
       </p:sp>
-      <p:sp>
-        <p:nvSpPr>
-          <p:cNvPr id="7" name=""/>
-          <p:cNvSpPr>
-            <a:spLocks noGrp="1"/>
-          </p:cNvSpPr>
-          <p:nvPr>
-            <p:ph/>
-          </p:nvPr>
-        </p:nvSpPr>
-        <p:spPr>
-          <a:xfrm>
-            <a:off x="457200" y="6510528"/>
-            <a:ext cx="8229600" cy="182880"/>
-          </a:xfrm>
-        </p:spPr>
-        <p:txBody>
-          <a:bodyPr/>
-          <a:lstStyle/>
-          <a:p>
-            <a:pPr algn="l" marL="0" marR="0">
-              <a:lnSpc>
-                <a:spcPct val="100000"/>
-              </a:lnSpc>
-              <a:spcBef>
-                <a:spcPts val="0"/>
-              </a:spcBef>
-              <a:spcAft>
-                <a:spcPts val="0"/>
-              </a:spcAft>
-              <a:buNone/>
-            </a:pPr>
-            <a:r>
-              <a:rPr cap="none" sz="900" i="0" b="0" u="none" strike="noStrike">
-                <a:solidFill>
-                  <a:srgbClr val="64748B">
-                    <a:alpha val="100000"/>
-                  </a:srgbClr>
-                </a:solidFill>
-                <a:latin typeface="Arial"/>
-                <a:cs typeface="Arial"/>
-                <a:ea typeface="Arial"/>
-                <a:sym typeface="Arial"/>
-              </a:rPr>
-              <a:t>DISCUSSION BACKUP  |  39</a:t>
-            </a:r>
-          </a:p>
-        </p:txBody>
-      </p:sp>
     </p:spTree>
   </p:cSld>
   <p:clrMapOvr>
@@ -13812,55 +12195,6 @@
           </a:p>
         </p:txBody>
       </p:sp>
-      <p:sp>
-        <p:nvSpPr>
-          <p:cNvPr id="6" name=""/>
-          <p:cNvSpPr>
-            <a:spLocks noGrp="1"/>
-          </p:cNvSpPr>
-          <p:nvPr>
-            <p:ph/>
-          </p:nvPr>
-        </p:nvSpPr>
-        <p:spPr>
-          <a:xfrm>
-            <a:off x="457200" y="6510528"/>
-            <a:ext cx="8229600" cy="182880"/>
-          </a:xfrm>
-        </p:spPr>
-        <p:txBody>
-          <a:bodyPr/>
-          <a:lstStyle/>
-          <a:p>
-            <a:pPr algn="l" marL="0" marR="0">
-              <a:lnSpc>
-                <a:spcPct val="100000"/>
-              </a:lnSpc>
-              <a:spcBef>
-                <a:spcPts val="0"/>
-              </a:spcBef>
-              <a:spcAft>
-                <a:spcPts val="0"/>
-              </a:spcAft>
-              <a:buNone/>
-            </a:pPr>
-            <a:r>
-              <a:rPr cap="none" sz="900" i="0" b="0" u="none" strike="noStrike">
-                <a:solidFill>
-                  <a:srgbClr val="64748B">
-                    <a:alpha val="100000"/>
-                  </a:srgbClr>
-                </a:solidFill>
-                <a:latin typeface="Arial"/>
-                <a:cs typeface="Arial"/>
-                <a:ea typeface="Arial"/>
-                <a:sym typeface="Arial"/>
-              </a:rPr>
-              <a:t>PRESENTATION RELEASE • 17 SEPT 2026  |  4</a:t>
-            </a:r>
-          </a:p>
-        </p:txBody>
-      </p:sp>
     </p:spTree>
   </p:cSld>
   <p:clrMapOvr>
@@ -14010,55 +12344,6 @@
           </a:prstGeom>
         </p:spPr>
       </p:pic>
-      <p:sp>
-        <p:nvSpPr>
-          <p:cNvPr id="5" name=""/>
-          <p:cNvSpPr>
-            <a:spLocks noGrp="1"/>
-          </p:cNvSpPr>
-          <p:nvPr>
-            <p:ph/>
-          </p:nvPr>
-        </p:nvSpPr>
-        <p:spPr>
-          <a:xfrm>
-            <a:off x="457200" y="6510528"/>
-            <a:ext cx="8229600" cy="182880"/>
-          </a:xfrm>
-        </p:spPr>
-        <p:txBody>
-          <a:bodyPr/>
-          <a:lstStyle/>
-          <a:p>
-            <a:pPr algn="l" marL="0" marR="0">
-              <a:lnSpc>
-                <a:spcPct val="100000"/>
-              </a:lnSpc>
-              <a:spcBef>
-                <a:spcPts val="0"/>
-              </a:spcBef>
-              <a:spcAft>
-                <a:spcPts val="0"/>
-              </a:spcAft>
-              <a:buNone/>
-            </a:pPr>
-            <a:r>
-              <a:rPr cap="none" sz="900" i="0" b="0" u="none" strike="noStrike">
-                <a:solidFill>
-                  <a:srgbClr val="64748B">
-                    <a:alpha val="100000"/>
-                  </a:srgbClr>
-                </a:solidFill>
-                <a:latin typeface="Arial"/>
-                <a:cs typeface="Arial"/>
-                <a:ea typeface="Arial"/>
-                <a:sym typeface="Arial"/>
-              </a:rPr>
-              <a:t>PRESENTATION RELEASE • 17 SEPT 2026  |  5</a:t>
-            </a:r>
-          </a:p>
-        </p:txBody>
-      </p:sp>
     </p:spTree>
   </p:cSld>
   <p:clrMapOvr>
@@ -14208,55 +12493,6 @@
           </a:prstGeom>
         </p:spPr>
       </p:pic>
-      <p:sp>
-        <p:nvSpPr>
-          <p:cNvPr id="5" name=""/>
-          <p:cNvSpPr>
-            <a:spLocks noGrp="1"/>
-          </p:cNvSpPr>
-          <p:nvPr>
-            <p:ph/>
-          </p:nvPr>
-        </p:nvSpPr>
-        <p:spPr>
-          <a:xfrm>
-            <a:off x="457200" y="6510528"/>
-            <a:ext cx="8229600" cy="182880"/>
-          </a:xfrm>
-        </p:spPr>
-        <p:txBody>
-          <a:bodyPr/>
-          <a:lstStyle/>
-          <a:p>
-            <a:pPr algn="l" marL="0" marR="0">
-              <a:lnSpc>
-                <a:spcPct val="100000"/>
-              </a:lnSpc>
-              <a:spcBef>
-                <a:spcPts val="0"/>
-              </a:spcBef>
-              <a:spcAft>
-                <a:spcPts val="0"/>
-              </a:spcAft>
-              <a:buNone/>
-            </a:pPr>
-            <a:r>
-              <a:rPr cap="none" sz="900" i="0" b="0" u="none" strike="noStrike">
-                <a:solidFill>
-                  <a:srgbClr val="64748B">
-                    <a:alpha val="100000"/>
-                  </a:srgbClr>
-                </a:solidFill>
-                <a:latin typeface="Arial"/>
-                <a:cs typeface="Arial"/>
-                <a:ea typeface="Arial"/>
-                <a:sym typeface="Arial"/>
-              </a:rPr>
-              <a:t>PRESENTATION RELEASE • 17 SEPT 2026  |  6</a:t>
-            </a:r>
-          </a:p>
-        </p:txBody>
-      </p:sp>
     </p:spTree>
   </p:cSld>
   <p:clrMapOvr>
@@ -14478,55 +12714,6 @@
           </a:p>
         </p:txBody>
       </p:sp>
-      <p:sp>
-        <p:nvSpPr>
-          <p:cNvPr id="6" name=""/>
-          <p:cNvSpPr>
-            <a:spLocks noGrp="1"/>
-          </p:cNvSpPr>
-          <p:nvPr>
-            <p:ph/>
-          </p:nvPr>
-        </p:nvSpPr>
-        <p:spPr>
-          <a:xfrm>
-            <a:off x="457200" y="6510528"/>
-            <a:ext cx="8229600" cy="182880"/>
-          </a:xfrm>
-        </p:spPr>
-        <p:txBody>
-          <a:bodyPr/>
-          <a:lstStyle/>
-          <a:p>
-            <a:pPr algn="l" marL="0" marR="0">
-              <a:lnSpc>
-                <a:spcPct val="100000"/>
-              </a:lnSpc>
-              <a:spcBef>
-                <a:spcPts val="0"/>
-              </a:spcBef>
-              <a:spcAft>
-                <a:spcPts val="0"/>
-              </a:spcAft>
-              <a:buNone/>
-            </a:pPr>
-            <a:r>
-              <a:rPr cap="none" sz="900" i="0" b="0" u="none" strike="noStrike">
-                <a:solidFill>
-                  <a:srgbClr val="64748B">
-                    <a:alpha val="100000"/>
-                  </a:srgbClr>
-                </a:solidFill>
-                <a:latin typeface="Arial"/>
-                <a:cs typeface="Arial"/>
-                <a:ea typeface="Arial"/>
-                <a:sym typeface="Arial"/>
-              </a:rPr>
-              <a:t>PRESENTATION RELEASE • 17 SEPT 2026  |  7</a:t>
-            </a:r>
-          </a:p>
-        </p:txBody>
-      </p:sp>
     </p:spTree>
   </p:cSld>
   <p:clrMapOvr>
@@ -14725,55 +12912,6 @@
           </a:prstGeom>
         </p:spPr>
       </p:pic>
-      <p:sp>
-        <p:nvSpPr>
-          <p:cNvPr id="6" name=""/>
-          <p:cNvSpPr>
-            <a:spLocks noGrp="1"/>
-          </p:cNvSpPr>
-          <p:nvPr>
-            <p:ph/>
-          </p:nvPr>
-        </p:nvSpPr>
-        <p:spPr>
-          <a:xfrm>
-            <a:off x="457200" y="6510528"/>
-            <a:ext cx="8229600" cy="182880"/>
-          </a:xfrm>
-        </p:spPr>
-        <p:txBody>
-          <a:bodyPr/>
-          <a:lstStyle/>
-          <a:p>
-            <a:pPr algn="l" marL="0" marR="0">
-              <a:lnSpc>
-                <a:spcPct val="100000"/>
-              </a:lnSpc>
-              <a:spcBef>
-                <a:spcPts val="0"/>
-              </a:spcBef>
-              <a:spcAft>
-                <a:spcPts val="0"/>
-              </a:spcAft>
-              <a:buNone/>
-            </a:pPr>
-            <a:r>
-              <a:rPr cap="none" sz="900" i="0" b="0" u="none" strike="noStrike">
-                <a:solidFill>
-                  <a:srgbClr val="64748B">
-                    <a:alpha val="100000"/>
-                  </a:srgbClr>
-                </a:solidFill>
-                <a:latin typeface="Arial"/>
-                <a:cs typeface="Arial"/>
-                <a:ea typeface="Arial"/>
-                <a:sym typeface="Arial"/>
-              </a:rPr>
-              <a:t>PRESENTATION RELEASE • 17 SEPT 2026  |  8</a:t>
-            </a:r>
-          </a:p>
-        </p:txBody>
-      </p:sp>
     </p:spTree>
   </p:cSld>
   <p:clrMapOvr>
@@ -15040,55 +13178,6 @@
                 <a:sym typeface="Arial"/>
               </a:rPr>
               <a:t>• Stress tests and prediction answer separate questions</a:t>
-            </a:r>
-          </a:p>
-        </p:txBody>
-      </p:sp>
-      <p:sp>
-        <p:nvSpPr>
-          <p:cNvPr id="7" name=""/>
-          <p:cNvSpPr>
-            <a:spLocks noGrp="1"/>
-          </p:cNvSpPr>
-          <p:nvPr>
-            <p:ph/>
-          </p:nvPr>
-        </p:nvSpPr>
-        <p:spPr>
-          <a:xfrm>
-            <a:off x="457200" y="6510528"/>
-            <a:ext cx="8229600" cy="182880"/>
-          </a:xfrm>
-        </p:spPr>
-        <p:txBody>
-          <a:bodyPr/>
-          <a:lstStyle/>
-          <a:p>
-            <a:pPr algn="l" marL="0" marR="0">
-              <a:lnSpc>
-                <a:spcPct val="100000"/>
-              </a:lnSpc>
-              <a:spcBef>
-                <a:spcPts val="0"/>
-              </a:spcBef>
-              <a:spcAft>
-                <a:spcPts val="0"/>
-              </a:spcAft>
-              <a:buNone/>
-            </a:pPr>
-            <a:r>
-              <a:rPr cap="none" sz="900" i="0" b="0" u="none" strike="noStrike">
-                <a:solidFill>
-                  <a:srgbClr val="64748B">
-                    <a:alpha val="100000"/>
-                  </a:srgbClr>
-                </a:solidFill>
-                <a:latin typeface="Arial"/>
-                <a:cs typeface="Arial"/>
-                <a:ea typeface="Arial"/>
-                <a:sym typeface="Arial"/>
-              </a:rPr>
-              <a:t>PRESENTATION RELEASE • 17 SEPT 2026  |  9</a:t>
             </a:r>
           </a:p>
         </p:txBody>

</xml_diff>